<commit_message>
Add designs-needed-to-start slide + Self-managed option to both tier decks
</commit_message>
<xml_diff>
--- a/Little-Blossoms-Tier1-Starter-Pitch.pptx
+++ b/Little-Blossoms-Tier1-Starter-Pitch.pptx
@@ -11,9 +11,11 @@
     <p:sldId id="259" r:id="rId5"/>
     <p:sldId id="260" r:id="rId6"/>
     <p:sldId id="261" r:id="rId7"/>
+    <p:sldId id="262" r:id="rId8"/>
+    <p:sldId id="263" r:id="rId9"/>
   </p:sldIdLst>
   <p:notesMasterIdLst>
-    <p:notesMasterId r:id="rId8"/>
+    <p:notesMasterId r:id="rId10"/>
   </p:notesMasterIdLst>
   <p:sldSz cx="12188952" cy="6858000"/>
   <p:notesSz cx="6858000" cy="12188952"/>
@@ -971,6 +973,182 @@
             <a:fld id="{F7021451-1387-4CA6-816F-3879F97B5CBC}" type="slidenum">
               <a:rPr lang="en-US"/>
               <a:t>6</a:t>
+            </a:fld>
+            <a:endParaRPr lang="en-US"/>
+          </a:p>
+        </p:txBody>
+      </p:sp>
+    </p:spTree>
+    <p:extLst>
+      <p:ext uri="{BB962C8B-B14F-4D97-AF65-F5344CB8AC3E}">
+        <p14:creationId xmlns:p14="http://schemas.microsoft.com/office/powerpoint/2010/main" val="1024086991"/>
+      </p:ext>
+    </p:extLst>
+  </p:cSld>
+  <p:clrMapOvr>
+    <a:masterClrMapping/>
+  </p:clrMapOvr>
+</p:notes>
+</file>
+
+<file path=ppt/notesSlides/notesSlide7.xml><?xml version="1.0" encoding="utf-8"?>
+<p:notes xmlns:a="http://schemas.openxmlformats.org/drawingml/2006/main" xmlns:r="http://schemas.openxmlformats.org/officeDocument/2006/relationships" xmlns:p="http://schemas.openxmlformats.org/presentationml/2006/main">
+  <p:cSld>
+    <p:spTree>
+      <p:nvGrpSpPr>
+        <p:cNvPr id="1" name=""/>
+        <p:cNvGrpSpPr/>
+        <p:nvPr/>
+      </p:nvGrpSpPr>
+      <p:grpSpPr>
+        <a:xfrm>
+          <a:off x="0" y="0"/>
+          <a:ext cx="0" cy="0"/>
+          <a:chOff x="0" y="0"/>
+          <a:chExt cx="0" cy="0"/>
+        </a:xfrm>
+      </p:grpSpPr>
+      <p:sp>
+        <p:nvSpPr>
+          <p:cNvPr id="2" name="Slide Image Placeholder 1"/>
+          <p:cNvSpPr>
+            <a:spLocks noGrp="1" noRot="1" noChangeAspect="1"/>
+          </p:cNvSpPr>
+          <p:nvPr>
+            <p:ph type="sldImg"/>
+          </p:nvPr>
+        </p:nvSpPr>
+        <p:spPr/>
+      </p:sp>
+      <p:sp>
+        <p:nvSpPr>
+          <p:cNvPr id="3" name="Notes Placeholder 2"/>
+          <p:cNvSpPr>
+            <a:spLocks noGrp="1"/>
+          </p:cNvSpPr>
+          <p:nvPr>
+            <p:ph type="body" idx="1"/>
+          </p:nvPr>
+        </p:nvSpPr>
+        <p:spPr/>
+        <p:txBody>
+          <a:bodyPr/>
+          <a:lstStyle/>
+          <a:p>
+            <a:r>
+              <a:rPr lang="en-US" dirty="0"/>
+              <a:t/>
+            </a:r>
+            <a:endParaRPr lang="en-US" dirty="0"/>
+          </a:p>
+        </p:txBody>
+      </p:sp>
+      <p:sp>
+        <p:nvSpPr>
+          <p:cNvPr id="4" name="Slide Number Placeholder 3"/>
+          <p:cNvSpPr>
+            <a:spLocks noGrp="1"/>
+          </p:cNvSpPr>
+          <p:nvPr>
+            <p:ph type="sldNum" sz="quarter" idx="10"/>
+          </p:nvPr>
+        </p:nvSpPr>
+        <p:spPr/>
+        <p:txBody>
+          <a:bodyPr/>
+          <a:lstStyle/>
+          <a:p>
+            <a:fld id="{F7021451-1387-4CA6-816F-3879F97B5CBC}" type="slidenum">
+              <a:rPr lang="en-US"/>
+              <a:t>7</a:t>
+            </a:fld>
+            <a:endParaRPr lang="en-US"/>
+          </a:p>
+        </p:txBody>
+      </p:sp>
+    </p:spTree>
+    <p:extLst>
+      <p:ext uri="{BB962C8B-B14F-4D97-AF65-F5344CB8AC3E}">
+        <p14:creationId xmlns:p14="http://schemas.microsoft.com/office/powerpoint/2010/main" val="1024086991"/>
+      </p:ext>
+    </p:extLst>
+  </p:cSld>
+  <p:clrMapOvr>
+    <a:masterClrMapping/>
+  </p:clrMapOvr>
+</p:notes>
+</file>
+
+<file path=ppt/notesSlides/notesSlide8.xml><?xml version="1.0" encoding="utf-8"?>
+<p:notes xmlns:a="http://schemas.openxmlformats.org/drawingml/2006/main" xmlns:r="http://schemas.openxmlformats.org/officeDocument/2006/relationships" xmlns:p="http://schemas.openxmlformats.org/presentationml/2006/main">
+  <p:cSld>
+    <p:spTree>
+      <p:nvGrpSpPr>
+        <p:cNvPr id="1" name=""/>
+        <p:cNvGrpSpPr/>
+        <p:nvPr/>
+      </p:nvGrpSpPr>
+      <p:grpSpPr>
+        <a:xfrm>
+          <a:off x="0" y="0"/>
+          <a:ext cx="0" cy="0"/>
+          <a:chOff x="0" y="0"/>
+          <a:chExt cx="0" cy="0"/>
+        </a:xfrm>
+      </p:grpSpPr>
+      <p:sp>
+        <p:nvSpPr>
+          <p:cNvPr id="2" name="Slide Image Placeholder 1"/>
+          <p:cNvSpPr>
+            <a:spLocks noGrp="1" noRot="1" noChangeAspect="1"/>
+          </p:cNvSpPr>
+          <p:nvPr>
+            <p:ph type="sldImg"/>
+          </p:nvPr>
+        </p:nvSpPr>
+        <p:spPr/>
+      </p:sp>
+      <p:sp>
+        <p:nvSpPr>
+          <p:cNvPr id="3" name="Notes Placeholder 2"/>
+          <p:cNvSpPr>
+            <a:spLocks noGrp="1"/>
+          </p:cNvSpPr>
+          <p:nvPr>
+            <p:ph type="body" idx="1"/>
+          </p:nvPr>
+        </p:nvSpPr>
+        <p:spPr/>
+        <p:txBody>
+          <a:bodyPr/>
+          <a:lstStyle/>
+          <a:p>
+            <a:r>
+              <a:rPr lang="en-US" dirty="0"/>
+              <a:t/>
+            </a:r>
+            <a:endParaRPr lang="en-US" dirty="0"/>
+          </a:p>
+        </p:txBody>
+      </p:sp>
+      <p:sp>
+        <p:nvSpPr>
+          <p:cNvPr id="4" name="Slide Number Placeholder 3"/>
+          <p:cNvSpPr>
+            <a:spLocks noGrp="1"/>
+          </p:cNvSpPr>
+          <p:nvPr>
+            <p:ph type="sldNum" sz="quarter" idx="10"/>
+          </p:nvPr>
+        </p:nvSpPr>
+        <p:spPr/>
+        <p:txBody>
+          <a:bodyPr/>
+          <a:lstStyle/>
+          <a:p>
+            <a:fld id="{F7021451-1387-4CA6-816F-3879F97B5CBC}" type="slidenum">
+              <a:rPr lang="en-US"/>
+              <a:t>8</a:t>
             </a:fld>
             <a:endParaRPr lang="en-US"/>
           </a:p>
@@ -1357,7 +1535,7 @@
         </p:nvSpPr>
         <p:spPr>
           <a:xfrm>
-            <a:off x="10424160" y="5303520"/>
+            <a:off x="10424160" y="-1097280"/>
             <a:ext cx="2651760" cy="2651760"/>
           </a:xfrm>
           <a:prstGeom prst="ellipse">
@@ -1514,8 +1692,8 @@
         </p:nvSpPr>
         <p:spPr>
           <a:xfrm>
-            <a:off x="914400" y="4206240"/>
-            <a:ext cx="9692640" cy="731520"/>
+            <a:off x="914400" y="4160520"/>
+            <a:ext cx="10241280" cy="731520"/>
           </a:xfrm>
           <a:prstGeom prst="rect">
             <a:avLst/>
@@ -1539,7 +1717,7 @@
                 <a:ea typeface="Calibri" pitchFamily="34" charset="-122"/>
                 <a:cs typeface="Calibri" pitchFamily="34" charset="-120"/>
               </a:rPr>
-              <a:t>A complete, mobile-friendly website with WhatsApp booking — delivered, hosted and supported</a:t>
+              <a:t>A complete, mobile-friendly website with WhatsApp booking — plus the designs you need to start</a:t>
             </a:r>
             <a:endParaRPr lang="en-US" sz="1700" dirty="0"/>
           </a:p>
@@ -1741,7 +1919,7 @@
         </p:nvSpPr>
         <p:spPr>
           <a:xfrm>
-            <a:off x="731520" y="1828800"/>
+            <a:off x="731520" y="1783080"/>
             <a:ext cx="457200" cy="457200"/>
           </a:xfrm>
           <a:prstGeom prst="oval">
@@ -1766,7 +1944,7 @@
         </p:nvSpPr>
         <p:spPr>
           <a:xfrm>
-            <a:off x="731520" y="1828800"/>
+            <a:off x="731520" y="1783080"/>
             <a:ext cx="457200" cy="457200"/>
           </a:xfrm>
           <a:prstGeom prst="rect">
@@ -1805,7 +1983,7 @@
         </p:nvSpPr>
         <p:spPr>
           <a:xfrm>
-            <a:off x="1371600" y="1810512"/>
+            <a:off x="1371600" y="1764792"/>
             <a:ext cx="2377440" cy="310896"/>
           </a:xfrm>
           <a:prstGeom prst="rect">
@@ -1844,7 +2022,7 @@
         </p:nvSpPr>
         <p:spPr>
           <a:xfrm>
-            <a:off x="3931920" y="1847088"/>
+            <a:off x="3931920" y="1801368"/>
             <a:ext cx="7315200" cy="457200"/>
           </a:xfrm>
           <a:prstGeom prst="rect">
@@ -1883,7 +2061,7 @@
         </p:nvSpPr>
         <p:spPr>
           <a:xfrm>
-            <a:off x="731520" y="2542032"/>
+            <a:off x="731520" y="2441448"/>
             <a:ext cx="457200" cy="457200"/>
           </a:xfrm>
           <a:prstGeom prst="oval">
@@ -1908,7 +2086,7 @@
         </p:nvSpPr>
         <p:spPr>
           <a:xfrm>
-            <a:off x="731520" y="2542032"/>
+            <a:off x="731520" y="2441448"/>
             <a:ext cx="457200" cy="457200"/>
           </a:xfrm>
           <a:prstGeom prst="rect">
@@ -1947,7 +2125,7 @@
         </p:nvSpPr>
         <p:spPr>
           <a:xfrm>
-            <a:off x="1371600" y="2523744"/>
+            <a:off x="1371600" y="2423160"/>
             <a:ext cx="2377440" cy="310896"/>
           </a:xfrm>
           <a:prstGeom prst="rect">
@@ -1986,7 +2164,7 @@
         </p:nvSpPr>
         <p:spPr>
           <a:xfrm>
-            <a:off x="3931920" y="2560320"/>
+            <a:off x="3931920" y="2459736"/>
             <a:ext cx="7315200" cy="457200"/>
           </a:xfrm>
           <a:prstGeom prst="rect">
@@ -2025,7 +2203,7 @@
         </p:nvSpPr>
         <p:spPr>
           <a:xfrm>
-            <a:off x="731520" y="3255264"/>
+            <a:off x="731520" y="3099816"/>
             <a:ext cx="457200" cy="457200"/>
           </a:xfrm>
           <a:prstGeom prst="oval">
@@ -2050,7 +2228,7 @@
         </p:nvSpPr>
         <p:spPr>
           <a:xfrm>
-            <a:off x="731520" y="3255264"/>
+            <a:off x="731520" y="3099816"/>
             <a:ext cx="457200" cy="457200"/>
           </a:xfrm>
           <a:prstGeom prst="rect">
@@ -2089,7 +2267,7 @@
         </p:nvSpPr>
         <p:spPr>
           <a:xfrm>
-            <a:off x="1371600" y="3236976"/>
+            <a:off x="1371600" y="3081528"/>
             <a:ext cx="2377440" cy="310896"/>
           </a:xfrm>
           <a:prstGeom prst="rect">
@@ -2128,7 +2306,7 @@
         </p:nvSpPr>
         <p:spPr>
           <a:xfrm>
-            <a:off x="3931920" y="3273552"/>
+            <a:off x="3931920" y="3118104"/>
             <a:ext cx="7315200" cy="457200"/>
           </a:xfrm>
           <a:prstGeom prst="rect">
@@ -2167,7 +2345,7 @@
         </p:nvSpPr>
         <p:spPr>
           <a:xfrm>
-            <a:off x="731520" y="3968496"/>
+            <a:off x="731520" y="3758184"/>
             <a:ext cx="457200" cy="457200"/>
           </a:xfrm>
           <a:prstGeom prst="oval">
@@ -2192,7 +2370,7 @@
         </p:nvSpPr>
         <p:spPr>
           <a:xfrm>
-            <a:off x="731520" y="3968496"/>
+            <a:off x="731520" y="3758184"/>
             <a:ext cx="457200" cy="457200"/>
           </a:xfrm>
           <a:prstGeom prst="rect">
@@ -2231,7 +2409,7 @@
         </p:nvSpPr>
         <p:spPr>
           <a:xfrm>
-            <a:off x="1371600" y="3950208"/>
+            <a:off x="1371600" y="3739896"/>
             <a:ext cx="2377440" cy="310896"/>
           </a:xfrm>
           <a:prstGeom prst="rect">
@@ -2270,7 +2448,7 @@
         </p:nvSpPr>
         <p:spPr>
           <a:xfrm>
-            <a:off x="3931920" y="3986784"/>
+            <a:off x="3931920" y="3776472"/>
             <a:ext cx="7315200" cy="457200"/>
           </a:xfrm>
           <a:prstGeom prst="rect">
@@ -2309,7 +2487,7 @@
         </p:nvSpPr>
         <p:spPr>
           <a:xfrm>
-            <a:off x="731520" y="4681728"/>
+            <a:off x="731520" y="4416552"/>
             <a:ext cx="457200" cy="457200"/>
           </a:xfrm>
           <a:prstGeom prst="oval">
@@ -2334,7 +2512,7 @@
         </p:nvSpPr>
         <p:spPr>
           <a:xfrm>
-            <a:off x="731520" y="4681728"/>
+            <a:off x="731520" y="4416552"/>
             <a:ext cx="457200" cy="457200"/>
           </a:xfrm>
           <a:prstGeom prst="rect">
@@ -2373,7 +2551,7 @@
         </p:nvSpPr>
         <p:spPr>
           <a:xfrm>
-            <a:off x="1371600" y="4663440"/>
+            <a:off x="1371600" y="4398264"/>
             <a:ext cx="2377440" cy="310896"/>
           </a:xfrm>
           <a:prstGeom prst="rect">
@@ -2412,7 +2590,7 @@
         </p:nvSpPr>
         <p:spPr>
           <a:xfrm>
-            <a:off x="3931920" y="4700016"/>
+            <a:off x="3931920" y="4434840"/>
             <a:ext cx="7315200" cy="457200"/>
           </a:xfrm>
           <a:prstGeom prst="rect">
@@ -2451,7 +2629,7 @@
         </p:nvSpPr>
         <p:spPr>
           <a:xfrm>
-            <a:off x="731520" y="5394960"/>
+            <a:off x="731520" y="5074920"/>
             <a:ext cx="457200" cy="457200"/>
           </a:xfrm>
           <a:prstGeom prst="oval">
@@ -2476,7 +2654,7 @@
         </p:nvSpPr>
         <p:spPr>
           <a:xfrm>
-            <a:off x="731520" y="5394960"/>
+            <a:off x="731520" y="5074920"/>
             <a:ext cx="457200" cy="457200"/>
           </a:xfrm>
           <a:prstGeom prst="rect">
@@ -2515,7 +2693,7 @@
         </p:nvSpPr>
         <p:spPr>
           <a:xfrm>
-            <a:off x="1371600" y="5376672"/>
+            <a:off x="1371600" y="5056632"/>
             <a:ext cx="2377440" cy="310896"/>
           </a:xfrm>
           <a:prstGeom prst="rect">
@@ -2554,7 +2732,7 @@
         </p:nvSpPr>
         <p:spPr>
           <a:xfrm>
-            <a:off x="3931920" y="5413248"/>
+            <a:off x="3931920" y="5093208"/>
             <a:ext cx="7315200" cy="457200"/>
           </a:xfrm>
           <a:prstGeom prst="rect">
@@ -2593,7 +2771,7 @@
         </p:nvSpPr>
         <p:spPr>
           <a:xfrm>
-            <a:off x="731520" y="6035040"/>
+            <a:off x="731520" y="5989320"/>
             <a:ext cx="10607040" cy="640080"/>
           </a:xfrm>
           <a:prstGeom prst="roundRect">
@@ -2620,7 +2798,7 @@
         </p:nvSpPr>
         <p:spPr>
           <a:xfrm>
-            <a:off x="731520" y="6035040"/>
+            <a:off x="731520" y="5989320"/>
             <a:ext cx="10607040" cy="640080"/>
           </a:xfrm>
           <a:prstGeom prst="rect">
@@ -2692,7 +2870,7 @@
         <p:spPr>
           <a:xfrm>
             <a:off x="731520" y="457200"/>
-            <a:ext cx="7315200" cy="731520"/>
+            <a:ext cx="10058400" cy="731520"/>
           </a:xfrm>
           <a:prstGeom prst="rect">
             <a:avLst/>
@@ -2716,7 +2894,7 @@
                 <a:ea typeface="Trebuchet MS" pitchFamily="34" charset="-122"/>
                 <a:cs typeface="Trebuchet MS" pitchFamily="34" charset="-120"/>
               </a:rPr>
-              <a:t>Pricing &amp; terms</a:t>
+              <a:t>Designs &amp; everything needed to start</a:t>
             </a:r>
             <a:endParaRPr lang="en-US" sz="3000" dirty="0"/>
           </a:p>
@@ -2724,34 +2902,78 @@
       </p:sp>
       <p:sp>
         <p:nvSpPr>
-          <p:cNvPr id="3" name="Shape 1"/>
-          <p:cNvSpPr/>
-          <p:nvPr/>
-        </p:nvSpPr>
-        <p:spPr>
-          <a:xfrm>
-            <a:off x="822960" y="1371600"/>
-            <a:ext cx="3108960" cy="685800"/>
-          </a:xfrm>
-          <a:prstGeom prst="rect">
+          <p:cNvPr id="3" name="Text 1"/>
+          <p:cNvSpPr/>
+          <p:nvPr/>
+        </p:nvSpPr>
+        <p:spPr>
+          <a:xfrm>
+            <a:off x="731520" y="1188720"/>
+            <a:ext cx="10424160" cy="457200"/>
+          </a:xfrm>
+          <a:prstGeom prst="rect">
+            <a:avLst/>
+          </a:prstGeom>
+          <a:noFill/>
+          <a:ln/>
+        </p:spPr>
+        <p:txBody>
+          <a:bodyPr wrap="square" rtlCol="0" anchor="ctr"/>
+          <a:lstStyle/>
+          <a:p>
+            <a:pPr indent="0" marL="0">
+              <a:buNone/>
+            </a:pPr>
+            <a:r>
+              <a:rPr lang="en-US" dirty="0">
+                <a:solidFill>
+                  <a:srgbClr val="725A4A"/>
+                </a:solidFill>
+                <a:latin typeface="Calibri" pitchFamily="34" charset="0"/>
+                <a:ea typeface="Calibri" pitchFamily="34" charset="-122"/>
+                <a:cs typeface="Calibri" pitchFamily="34" charset="-120"/>
+              </a:rPr>
+              <a:t>We don’t just build the site — we give you the designs it needs and everything required to go live</a:t>
+            </a:r>
+            <a:endParaRPr lang="en-US" dirty="0"/>
+          </a:p>
+        </p:txBody>
+      </p:sp>
+      <p:sp>
+        <p:nvSpPr>
+          <p:cNvPr id="4" name="Shape 2"/>
+          <p:cNvSpPr/>
+          <p:nvPr/>
+        </p:nvSpPr>
+        <p:spPr>
+          <a:xfrm>
+            <a:off x="822960" y="1920240"/>
+            <a:ext cx="457200" cy="457200"/>
+          </a:xfrm>
+          <a:prstGeom prst="oval">
             <a:avLst/>
           </a:prstGeom>
           <a:solidFill>
-            <a:srgbClr val="F3EDFB"/>
+            <a:srgbClr val="2EC4B6"/>
           </a:solidFill>
-          <a:ln/>
-        </p:spPr>
-      </p:sp>
-      <p:sp>
-        <p:nvSpPr>
-          <p:cNvPr id="4" name="Text 2"/>
-          <p:cNvSpPr/>
-          <p:nvPr/>
-        </p:nvSpPr>
-        <p:spPr>
-          <a:xfrm>
-            <a:off x="822960" y="1371600"/>
-            <a:ext cx="3108960" cy="685800"/>
+          <a:ln w="12700">
+            <a:solidFill>
+              <a:srgbClr val="2EC4B6"/>
+            </a:solidFill>
+            <a:prstDash val="solid"/>
+          </a:ln>
+        </p:spPr>
+      </p:sp>
+      <p:sp>
+        <p:nvSpPr>
+          <p:cNvPr id="5" name="Text 3"/>
+          <p:cNvSpPr/>
+          <p:nvPr/>
+        </p:nvSpPr>
+        <p:spPr>
+          <a:xfrm>
+            <a:off x="822960" y="1920240"/>
+            <a:ext cx="457200" cy="457200"/>
           </a:xfrm>
           <a:prstGeom prst="rect">
             <a:avLst/>
@@ -2767,30 +2989,30 @@
               <a:buNone/>
             </a:pPr>
             <a:r>
-              <a:rPr lang="en-US" sz="1400" b="1" dirty="0">
-                <a:solidFill>
-                  <a:srgbClr val="6F2DBD"/>
+              <a:rPr lang="en-US" sz="1600" b="1" dirty="0">
+                <a:solidFill>
+                  <a:srgbClr val="FFFFFF"/>
                 </a:solidFill>
                 <a:latin typeface="Trebuchet MS" pitchFamily="34" charset="0"/>
                 <a:ea typeface="Trebuchet MS" pitchFamily="34" charset="-122"/>
                 <a:cs typeface="Trebuchet MS" pitchFamily="34" charset="-120"/>
               </a:rPr>
-              <a:t>Website build</a:t>
-            </a:r>
-            <a:endParaRPr lang="en-US" sz="1400" dirty="0"/>
-          </a:p>
-        </p:txBody>
-      </p:sp>
-      <p:sp>
-        <p:nvSpPr>
-          <p:cNvPr id="5" name="Text 3"/>
-          <p:cNvSpPr/>
-          <p:nvPr/>
-        </p:nvSpPr>
-        <p:spPr>
-          <a:xfrm>
-            <a:off x="4114800" y="1371600"/>
-            <a:ext cx="2926080" cy="685800"/>
+              <a:t>1</a:t>
+            </a:r>
+            <a:endParaRPr lang="en-US" sz="1600" dirty="0"/>
+          </a:p>
+        </p:txBody>
+      </p:sp>
+      <p:sp>
+        <p:nvSpPr>
+          <p:cNvPr id="6" name="Text 4"/>
+          <p:cNvSpPr/>
+          <p:nvPr/>
+        </p:nvSpPr>
+        <p:spPr>
+          <a:xfrm>
+            <a:off x="1463040" y="1892808"/>
+            <a:ext cx="3291840" cy="365760"/>
           </a:xfrm>
           <a:prstGeom prst="rect">
             <a:avLst/>
@@ -2806,7 +3028,7 @@
               <a:buNone/>
             </a:pPr>
             <a:r>
-              <a:rPr lang="en-US" sz="1500" b="1" dirty="0">
+              <a:rPr lang="en-US" sz="1600" b="1" dirty="0">
                 <a:solidFill>
                   <a:srgbClr val="3A2E29"/>
                 </a:solidFill>
@@ -2814,22 +3036,22 @@
                 <a:ea typeface="Trebuchet MS" pitchFamily="34" charset="-122"/>
                 <a:cs typeface="Trebuchet MS" pitchFamily="34" charset="-120"/>
               </a:rPr>
-              <a:t>Rs 50,000</a:t>
-            </a:r>
-            <a:endParaRPr lang="en-US" sz="1500" dirty="0"/>
-          </a:p>
-        </p:txBody>
-      </p:sp>
-      <p:sp>
-        <p:nvSpPr>
-          <p:cNvPr id="6" name="Text 4"/>
-          <p:cNvSpPr/>
-          <p:nvPr/>
-        </p:nvSpPr>
-        <p:spPr>
-          <a:xfrm>
-            <a:off x="7223760" y="1371600"/>
-            <a:ext cx="4206240" cy="685800"/>
+              <a:t>Additional designs</a:t>
+            </a:r>
+            <a:endParaRPr lang="en-US" sz="1600" dirty="0"/>
+          </a:p>
+        </p:txBody>
+      </p:sp>
+      <p:sp>
+        <p:nvSpPr>
+          <p:cNvPr id="7" name="Text 5"/>
+          <p:cNvSpPr/>
+          <p:nvPr/>
+        </p:nvSpPr>
+        <p:spPr>
+          <a:xfrm>
+            <a:off x="4846320" y="1938528"/>
+            <a:ext cx="6583680" cy="777240"/>
           </a:xfrm>
           <a:prstGeom prst="rect">
             <a:avLst/>
@@ -2853,7 +3075,7 @@
                 <a:ea typeface="Calibri" pitchFamily="34" charset="-122"/>
                 <a:cs typeface="Calibri" pitchFamily="34" charset="-120"/>
               </a:rPr>
-              <a:t>Design, development, testing, deploy</a:t>
+              <a:t>Logos, banners, icons, poster/brochure graphics, social-media creatives — designed for you in your brand style</a:t>
             </a:r>
             <a:endParaRPr lang="en-US" dirty="0"/>
           </a:p>
@@ -2861,34 +3083,39 @@
       </p:sp>
       <p:sp>
         <p:nvSpPr>
-          <p:cNvPr id="7" name="Shape 5"/>
-          <p:cNvSpPr/>
-          <p:nvPr/>
-        </p:nvSpPr>
-        <p:spPr>
-          <a:xfrm>
-            <a:off x="822960" y="2240280"/>
-            <a:ext cx="3108960" cy="685800"/>
-          </a:xfrm>
-          <a:prstGeom prst="rect">
+          <p:cNvPr id="8" name="Shape 6"/>
+          <p:cNvSpPr/>
+          <p:nvPr/>
+        </p:nvSpPr>
+        <p:spPr>
+          <a:xfrm>
+            <a:off x="822960" y="2880360"/>
+            <a:ext cx="457200" cy="457200"/>
+          </a:xfrm>
+          <a:prstGeom prst="oval">
             <a:avLst/>
           </a:prstGeom>
           <a:solidFill>
-            <a:srgbClr val="F3EDFB"/>
+            <a:srgbClr val="2EC4B6"/>
           </a:solidFill>
-          <a:ln/>
-        </p:spPr>
-      </p:sp>
-      <p:sp>
-        <p:nvSpPr>
-          <p:cNvPr id="8" name="Text 6"/>
-          <p:cNvSpPr/>
-          <p:nvPr/>
-        </p:nvSpPr>
-        <p:spPr>
-          <a:xfrm>
-            <a:off x="822960" y="2240280"/>
-            <a:ext cx="3108960" cy="685800"/>
+          <a:ln w="12700">
+            <a:solidFill>
+              <a:srgbClr val="2EC4B6"/>
+            </a:solidFill>
+            <a:prstDash val="solid"/>
+          </a:ln>
+        </p:spPr>
+      </p:sp>
+      <p:sp>
+        <p:nvSpPr>
+          <p:cNvPr id="9" name="Text 7"/>
+          <p:cNvSpPr/>
+          <p:nvPr/>
+        </p:nvSpPr>
+        <p:spPr>
+          <a:xfrm>
+            <a:off x="822960" y="2880360"/>
+            <a:ext cx="457200" cy="457200"/>
           </a:xfrm>
           <a:prstGeom prst="rect">
             <a:avLst/>
@@ -2904,30 +3131,30 @@
               <a:buNone/>
             </a:pPr>
             <a:r>
-              <a:rPr lang="en-US" sz="1400" b="1" dirty="0">
-                <a:solidFill>
-                  <a:srgbClr val="6F2DBD"/>
+              <a:rPr lang="en-US" sz="1600" b="1" dirty="0">
+                <a:solidFill>
+                  <a:srgbClr val="FFFFFF"/>
                 </a:solidFill>
                 <a:latin typeface="Trebuchet MS" pitchFamily="34" charset="0"/>
                 <a:ea typeface="Trebuchet MS" pitchFamily="34" charset="-122"/>
                 <a:cs typeface="Trebuchet MS" pitchFamily="34" charset="-120"/>
               </a:rPr>
-              <a:t>Domain</a:t>
-            </a:r>
-            <a:endParaRPr lang="en-US" sz="1400" dirty="0"/>
-          </a:p>
-        </p:txBody>
-      </p:sp>
-      <p:sp>
-        <p:nvSpPr>
-          <p:cNvPr id="9" name="Text 7"/>
-          <p:cNvSpPr/>
-          <p:nvPr/>
-        </p:nvSpPr>
-        <p:spPr>
-          <a:xfrm>
-            <a:off x="4114800" y="2240280"/>
-            <a:ext cx="2926080" cy="685800"/>
+              <a:t>2</a:t>
+            </a:r>
+            <a:endParaRPr lang="en-US" sz="1600" dirty="0"/>
+          </a:p>
+        </p:txBody>
+      </p:sp>
+      <p:sp>
+        <p:nvSpPr>
+          <p:cNvPr id="10" name="Text 8"/>
+          <p:cNvSpPr/>
+          <p:nvPr/>
+        </p:nvSpPr>
+        <p:spPr>
+          <a:xfrm>
+            <a:off x="1463040" y="2852928"/>
+            <a:ext cx="3291840" cy="365760"/>
           </a:xfrm>
           <a:prstGeom prst="rect">
             <a:avLst/>
@@ -2943,7 +3170,7 @@
               <a:buNone/>
             </a:pPr>
             <a:r>
-              <a:rPr lang="en-US" sz="1500" b="1" dirty="0">
+              <a:rPr lang="en-US" sz="1600" b="1" dirty="0">
                 <a:solidFill>
                   <a:srgbClr val="3A2E29"/>
                 </a:solidFill>
@@ -2951,22 +3178,22 @@
                 <a:ea typeface="Trebuchet MS" pitchFamily="34" charset="-122"/>
                 <a:cs typeface="Trebuchet MS" pitchFamily="34" charset="-120"/>
               </a:rPr>
-              <a:t>Actual cost</a:t>
-            </a:r>
-            <a:endParaRPr lang="en-US" sz="1500" dirty="0"/>
-          </a:p>
-        </p:txBody>
-      </p:sp>
-      <p:sp>
-        <p:nvSpPr>
-          <p:cNvPr id="10" name="Text 8"/>
-          <p:cNvSpPr/>
-          <p:nvPr/>
-        </p:nvSpPr>
-        <p:spPr>
-          <a:xfrm>
-            <a:off x="7223760" y="2240280"/>
-            <a:ext cx="4206240" cy="685800"/>
+              <a:t>Photos &amp; content</a:t>
+            </a:r>
+            <a:endParaRPr lang="en-US" sz="1600" dirty="0"/>
+          </a:p>
+        </p:txBody>
+      </p:sp>
+      <p:sp>
+        <p:nvSpPr>
+          <p:cNvPr id="11" name="Text 9"/>
+          <p:cNvSpPr/>
+          <p:nvPr/>
+        </p:nvSpPr>
+        <p:spPr>
+          <a:xfrm>
+            <a:off x="4846320" y="2898648"/>
+            <a:ext cx="6583680" cy="777240"/>
           </a:xfrm>
           <a:prstGeom prst="rect">
             <a:avLst/>
@@ -2990,7 +3217,7 @@
                 <a:ea typeface="Calibri" pitchFamily="34" charset="-122"/>
                 <a:cs typeface="Calibri" pitchFamily="34" charset="-120"/>
               </a:rPr>
-              <a:t>Billed directly by the registrar (e.g. .in or .com)</a:t>
+              <a:t>Use your photos or we guide you — we advise and prepare what the site needs</a:t>
             </a:r>
             <a:endParaRPr lang="en-US" dirty="0"/>
           </a:p>
@@ -2998,34 +3225,39 @@
       </p:sp>
       <p:sp>
         <p:nvSpPr>
-          <p:cNvPr id="11" name="Shape 9"/>
-          <p:cNvSpPr/>
-          <p:nvPr/>
-        </p:nvSpPr>
-        <p:spPr>
-          <a:xfrm>
-            <a:off x="822960" y="3108960"/>
-            <a:ext cx="3108960" cy="685800"/>
-          </a:xfrm>
-          <a:prstGeom prst="rect">
+          <p:cNvPr id="12" name="Shape 10"/>
+          <p:cNvSpPr/>
+          <p:nvPr/>
+        </p:nvSpPr>
+        <p:spPr>
+          <a:xfrm>
+            <a:off x="822960" y="3840480"/>
+            <a:ext cx="457200" cy="457200"/>
+          </a:xfrm>
+          <a:prstGeom prst="oval">
             <a:avLst/>
           </a:prstGeom>
           <a:solidFill>
-            <a:srgbClr val="F3EDFB"/>
+            <a:srgbClr val="2EC4B6"/>
           </a:solidFill>
-          <a:ln/>
-        </p:spPr>
-      </p:sp>
-      <p:sp>
-        <p:nvSpPr>
-          <p:cNvPr id="12" name="Text 10"/>
-          <p:cNvSpPr/>
-          <p:nvPr/>
-        </p:nvSpPr>
-        <p:spPr>
-          <a:xfrm>
-            <a:off x="822960" y="3108960"/>
-            <a:ext cx="3108960" cy="685800"/>
+          <a:ln w="12700">
+            <a:solidFill>
+              <a:srgbClr val="2EC4B6"/>
+            </a:solidFill>
+            <a:prstDash val="solid"/>
+          </a:ln>
+        </p:spPr>
+      </p:sp>
+      <p:sp>
+        <p:nvSpPr>
+          <p:cNvPr id="13" name="Text 11"/>
+          <p:cNvSpPr/>
+          <p:nvPr/>
+        </p:nvSpPr>
+        <p:spPr>
+          <a:xfrm>
+            <a:off x="822960" y="3840480"/>
+            <a:ext cx="457200" cy="457200"/>
           </a:xfrm>
           <a:prstGeom prst="rect">
             <a:avLst/>
@@ -3041,30 +3273,30 @@
               <a:buNone/>
             </a:pPr>
             <a:r>
-              <a:rPr lang="en-US" sz="1400" b="1" dirty="0">
-                <a:solidFill>
-                  <a:srgbClr val="6F2DBD"/>
+              <a:rPr lang="en-US" sz="1600" b="1" dirty="0">
+                <a:solidFill>
+                  <a:srgbClr val="FFFFFF"/>
                 </a:solidFill>
                 <a:latin typeface="Trebuchet MS" pitchFamily="34" charset="0"/>
                 <a:ea typeface="Trebuchet MS" pitchFamily="34" charset="-122"/>
                 <a:cs typeface="Trebuchet MS" pitchFamily="34" charset="-120"/>
               </a:rPr>
-              <a:t>Hosting</a:t>
-            </a:r>
-            <a:endParaRPr lang="en-US" sz="1400" dirty="0"/>
-          </a:p>
-        </p:txBody>
-      </p:sp>
-      <p:sp>
-        <p:nvSpPr>
-          <p:cNvPr id="13" name="Text 11"/>
-          <p:cNvSpPr/>
-          <p:nvPr/>
-        </p:nvSpPr>
-        <p:spPr>
-          <a:xfrm>
-            <a:off x="4114800" y="3108960"/>
-            <a:ext cx="2926080" cy="685800"/>
+              <a:t>3</a:t>
+            </a:r>
+            <a:endParaRPr lang="en-US" sz="1600" dirty="0"/>
+          </a:p>
+        </p:txBody>
+      </p:sp>
+      <p:sp>
+        <p:nvSpPr>
+          <p:cNvPr id="14" name="Text 12"/>
+          <p:cNvSpPr/>
+          <p:nvPr/>
+        </p:nvSpPr>
+        <p:spPr>
+          <a:xfrm>
+            <a:off x="1463040" y="3813048"/>
+            <a:ext cx="3291840" cy="365760"/>
           </a:xfrm>
           <a:prstGeom prst="rect">
             <a:avLst/>
@@ -3080,7 +3312,7 @@
               <a:buNone/>
             </a:pPr>
             <a:r>
-              <a:rPr lang="en-US" sz="1500" b="1" dirty="0">
+              <a:rPr lang="en-US" sz="1600" b="1" dirty="0">
                 <a:solidFill>
                   <a:srgbClr val="3A2E29"/>
                 </a:solidFill>
@@ -3088,22 +3320,22 @@
                 <a:ea typeface="Trebuchet MS" pitchFamily="34" charset="-122"/>
                 <a:cs typeface="Trebuchet MS" pitchFamily="34" charset="-120"/>
               </a:rPr>
-              <a:t>Included first year</a:t>
-            </a:r>
-            <a:endParaRPr lang="en-US" sz="1500" dirty="0"/>
-          </a:p>
-        </p:txBody>
-      </p:sp>
-      <p:sp>
-        <p:nvSpPr>
-          <p:cNvPr id="14" name="Text 12"/>
-          <p:cNvSpPr/>
-          <p:nvPr/>
-        </p:nvSpPr>
-        <p:spPr>
-          <a:xfrm>
-            <a:off x="7223760" y="3108960"/>
-            <a:ext cx="4206240" cy="685800"/>
+              <a:t>Domain &amp; hosting</a:t>
+            </a:r>
+            <a:endParaRPr lang="en-US" sz="1600" dirty="0"/>
+          </a:p>
+        </p:txBody>
+      </p:sp>
+      <p:sp>
+        <p:nvSpPr>
+          <p:cNvPr id="15" name="Text 13"/>
+          <p:cNvSpPr/>
+          <p:nvPr/>
+        </p:nvSpPr>
+        <p:spPr>
+          <a:xfrm>
+            <a:off x="4846320" y="3858768"/>
+            <a:ext cx="6583680" cy="777240"/>
           </a:xfrm>
           <a:prstGeom prst="rect">
             <a:avLst/>
@@ -3127,7 +3359,7 @@
                 <a:ea typeface="Calibri" pitchFamily="34" charset="-122"/>
                 <a:cs typeface="Calibri" pitchFamily="34" charset="-120"/>
               </a:rPr>
-              <a:t>Fast, secure hosting on our platform</a:t>
+              <a:t>We suggest and set up your domain (e.g. littleblossoms.in) and hosting</a:t>
             </a:r>
             <a:endParaRPr lang="en-US" dirty="0"/>
           </a:p>
@@ -3135,34 +3367,39 @@
       </p:sp>
       <p:sp>
         <p:nvSpPr>
-          <p:cNvPr id="15" name="Shape 13"/>
-          <p:cNvSpPr/>
-          <p:nvPr/>
-        </p:nvSpPr>
-        <p:spPr>
-          <a:xfrm>
-            <a:off x="822960" y="3977640"/>
-            <a:ext cx="3108960" cy="685800"/>
-          </a:xfrm>
-          <a:prstGeom prst="rect">
+          <p:cNvPr id="16" name="Shape 14"/>
+          <p:cNvSpPr/>
+          <p:nvPr/>
+        </p:nvSpPr>
+        <p:spPr>
+          <a:xfrm>
+            <a:off x="822960" y="4800600"/>
+            <a:ext cx="457200" cy="457200"/>
+          </a:xfrm>
+          <a:prstGeom prst="oval">
             <a:avLst/>
           </a:prstGeom>
           <a:solidFill>
-            <a:srgbClr val="F3EDFB"/>
+            <a:srgbClr val="2EC4B6"/>
           </a:solidFill>
-          <a:ln/>
-        </p:spPr>
-      </p:sp>
-      <p:sp>
-        <p:nvSpPr>
-          <p:cNvPr id="16" name="Text 14"/>
-          <p:cNvSpPr/>
-          <p:nvPr/>
-        </p:nvSpPr>
-        <p:spPr>
-          <a:xfrm>
-            <a:off x="822960" y="3977640"/>
-            <a:ext cx="3108960" cy="685800"/>
+          <a:ln w="12700">
+            <a:solidFill>
+              <a:srgbClr val="2EC4B6"/>
+            </a:solidFill>
+            <a:prstDash val="solid"/>
+          </a:ln>
+        </p:spPr>
+      </p:sp>
+      <p:sp>
+        <p:nvSpPr>
+          <p:cNvPr id="17" name="Text 15"/>
+          <p:cNvSpPr/>
+          <p:nvPr/>
+        </p:nvSpPr>
+        <p:spPr>
+          <a:xfrm>
+            <a:off x="822960" y="4800600"/>
+            <a:ext cx="457200" cy="457200"/>
           </a:xfrm>
           <a:prstGeom prst="rect">
             <a:avLst/>
@@ -3178,30 +3415,30 @@
               <a:buNone/>
             </a:pPr>
             <a:r>
-              <a:rPr lang="en-US" sz="1400" b="1" dirty="0">
-                <a:solidFill>
-                  <a:srgbClr val="6F2DBD"/>
+              <a:rPr lang="en-US" sz="1600" b="1" dirty="0">
+                <a:solidFill>
+                  <a:srgbClr val="FFFFFF"/>
                 </a:solidFill>
                 <a:latin typeface="Trebuchet MS" pitchFamily="34" charset="0"/>
                 <a:ea typeface="Trebuchet MS" pitchFamily="34" charset="-122"/>
                 <a:cs typeface="Trebuchet MS" pitchFamily="34" charset="-120"/>
               </a:rPr>
-              <a:t>Support</a:t>
-            </a:r>
-            <a:endParaRPr lang="en-US" sz="1400" dirty="0"/>
-          </a:p>
-        </p:txBody>
-      </p:sp>
-      <p:sp>
-        <p:nvSpPr>
-          <p:cNvPr id="17" name="Text 15"/>
-          <p:cNvSpPr/>
-          <p:nvPr/>
-        </p:nvSpPr>
-        <p:spPr>
-          <a:xfrm>
-            <a:off x="4114800" y="3977640"/>
-            <a:ext cx="2926080" cy="685800"/>
+              <a:t>4</a:t>
+            </a:r>
+            <a:endParaRPr lang="en-US" sz="1600" dirty="0"/>
+          </a:p>
+        </p:txBody>
+      </p:sp>
+      <p:sp>
+        <p:nvSpPr>
+          <p:cNvPr id="18" name="Text 16"/>
+          <p:cNvSpPr/>
+          <p:nvPr/>
+        </p:nvSpPr>
+        <p:spPr>
+          <a:xfrm>
+            <a:off x="1463040" y="4773168"/>
+            <a:ext cx="3291840" cy="365760"/>
           </a:xfrm>
           <a:prstGeom prst="rect">
             <a:avLst/>
@@ -3217,7 +3454,7 @@
               <a:buNone/>
             </a:pPr>
             <a:r>
-              <a:rPr lang="en-US" sz="1500" b="1" dirty="0">
+              <a:rPr lang="en-US" sz="1600" b="1" dirty="0">
                 <a:solidFill>
                   <a:srgbClr val="3A2E29"/>
                 </a:solidFill>
@@ -3225,22 +3462,22 @@
                 <a:ea typeface="Trebuchet MS" pitchFamily="34" charset="-122"/>
                 <a:cs typeface="Trebuchet MS" pitchFamily="34" charset="-120"/>
               </a:rPr>
-              <a:t>3 months</a:t>
-            </a:r>
-            <a:endParaRPr lang="en-US" sz="1500" dirty="0"/>
-          </a:p>
-        </p:txBody>
-      </p:sp>
-      <p:sp>
-        <p:nvSpPr>
-          <p:cNvPr id="18" name="Text 16"/>
-          <p:cNvSpPr/>
-          <p:nvPr/>
-        </p:nvSpPr>
-        <p:spPr>
-          <a:xfrm>
-            <a:off x="7223760" y="3977640"/>
-            <a:ext cx="4206240" cy="685800"/>
+              <a:t>Start checklist</a:t>
+            </a:r>
+            <a:endParaRPr lang="en-US" sz="1600" dirty="0"/>
+          </a:p>
+        </p:txBody>
+      </p:sp>
+      <p:sp>
+        <p:nvSpPr>
+          <p:cNvPr id="19" name="Text 17"/>
+          <p:cNvSpPr/>
+          <p:nvPr/>
+        </p:nvSpPr>
+        <p:spPr>
+          <a:xfrm>
+            <a:off x="4846320" y="4818888"/>
+            <a:ext cx="6583680" cy="777240"/>
           </a:xfrm>
           <a:prstGeom prst="rect">
             <a:avLst/>
@@ -3264,7 +3501,7 @@
                 <a:ea typeface="Calibri" pitchFamily="34" charset="-122"/>
                 <a:cs typeface="Calibri" pitchFamily="34" charset="-120"/>
               </a:rPr>
-              <a:t>Issues resolved free for 3 months after launch</a:t>
+              <a:t>Name, logo, photos, basic text, contact details, preferred domain — we walk you through it</a:t>
             </a:r>
             <a:endParaRPr lang="en-US" dirty="0"/>
           </a:p>
@@ -3272,155 +3509,18 @@
       </p:sp>
       <p:sp>
         <p:nvSpPr>
-          <p:cNvPr id="19" name="Shape 17"/>
-          <p:cNvSpPr/>
-          <p:nvPr/>
-        </p:nvSpPr>
-        <p:spPr>
-          <a:xfrm>
-            <a:off x="822960" y="4846320"/>
-            <a:ext cx="3108960" cy="685800"/>
-          </a:xfrm>
-          <a:prstGeom prst="rect">
-            <a:avLst/>
-          </a:prstGeom>
-          <a:solidFill>
-            <a:srgbClr val="F3EDFB"/>
-          </a:solidFill>
-          <a:ln/>
-        </p:spPr>
-      </p:sp>
-      <p:sp>
-        <p:nvSpPr>
-          <p:cNvPr id="20" name="Text 18"/>
-          <p:cNvSpPr/>
-          <p:nvPr/>
-        </p:nvSpPr>
-        <p:spPr>
-          <a:xfrm>
-            <a:off x="822960" y="4846320"/>
-            <a:ext cx="3108960" cy="685800"/>
-          </a:xfrm>
-          <a:prstGeom prst="rect">
-            <a:avLst/>
-          </a:prstGeom>
-          <a:noFill/>
-          <a:ln/>
-        </p:spPr>
-        <p:txBody>
-          <a:bodyPr wrap="square" rtlCol="0" anchor="ctr"/>
-          <a:lstStyle/>
-          <a:p>
-            <a:pPr algn="ctr" indent="0" marL="0">
-              <a:buNone/>
-            </a:pPr>
-            <a:r>
-              <a:rPr lang="en-US" sz="1400" b="1" dirty="0">
-                <a:solidFill>
-                  <a:srgbClr val="6F2DBD"/>
-                </a:solidFill>
-                <a:latin typeface="Trebuchet MS" pitchFamily="34" charset="0"/>
-                <a:ea typeface="Trebuchet MS" pitchFamily="34" charset="-122"/>
-                <a:cs typeface="Trebuchet MS" pitchFamily="34" charset="-120"/>
-              </a:rPr>
-              <a:t>Timeline</a:t>
-            </a:r>
-            <a:endParaRPr lang="en-US" sz="1400" dirty="0"/>
-          </a:p>
-        </p:txBody>
-      </p:sp>
-      <p:sp>
-        <p:nvSpPr>
-          <p:cNvPr id="21" name="Text 19"/>
-          <p:cNvSpPr/>
-          <p:nvPr/>
-        </p:nvSpPr>
-        <p:spPr>
-          <a:xfrm>
-            <a:off x="4114800" y="4846320"/>
-            <a:ext cx="2926080" cy="685800"/>
-          </a:xfrm>
-          <a:prstGeom prst="rect">
-            <a:avLst/>
-          </a:prstGeom>
-          <a:noFill/>
-          <a:ln/>
-        </p:spPr>
-        <p:txBody>
-          <a:bodyPr wrap="square" rtlCol="0" anchor="ctr"/>
-          <a:lstStyle/>
-          <a:p>
-            <a:pPr indent="0" marL="0">
-              <a:buNone/>
-            </a:pPr>
-            <a:r>
-              <a:rPr lang="en-US" sz="1500" b="1" dirty="0">
-                <a:solidFill>
-                  <a:srgbClr val="3A2E29"/>
-                </a:solidFill>
-                <a:latin typeface="Trebuchet MS" pitchFamily="34" charset="0"/>
-                <a:ea typeface="Trebuchet MS" pitchFamily="34" charset="-122"/>
-                <a:cs typeface="Trebuchet MS" pitchFamily="34" charset="-120"/>
-              </a:rPr>
-              <a:t>4–6 weeks</a:t>
-            </a:r>
-            <a:endParaRPr lang="en-US" sz="1500" dirty="0"/>
-          </a:p>
-        </p:txBody>
-      </p:sp>
-      <p:sp>
-        <p:nvSpPr>
-          <p:cNvPr id="22" name="Text 20"/>
-          <p:cNvSpPr/>
-          <p:nvPr/>
-        </p:nvSpPr>
-        <p:spPr>
-          <a:xfrm>
-            <a:off x="7223760" y="4846320"/>
-            <a:ext cx="4206240" cy="685800"/>
-          </a:xfrm>
-          <a:prstGeom prst="rect">
-            <a:avLst/>
-          </a:prstGeom>
-          <a:noFill/>
-          <a:ln/>
-        </p:spPr>
-        <p:txBody>
-          <a:bodyPr wrap="square" rtlCol="0" anchor="ctr"/>
-          <a:lstStyle/>
-          <a:p>
-            <a:pPr indent="0" marL="0">
-              <a:buNone/>
-            </a:pPr>
-            <a:r>
-              <a:rPr lang="en-US" dirty="0">
-                <a:solidFill>
-                  <a:srgbClr val="725A4A"/>
-                </a:solidFill>
-                <a:latin typeface="Calibri" pitchFamily="34" charset="0"/>
-                <a:ea typeface="Calibri" pitchFamily="34" charset="-122"/>
-                <a:cs typeface="Calibri" pitchFamily="34" charset="-120"/>
-              </a:rPr>
-              <a:t>From content handover to live site</a:t>
-            </a:r>
-            <a:endParaRPr lang="en-US" dirty="0"/>
-          </a:p>
-        </p:txBody>
-      </p:sp>
-      <p:sp>
-        <p:nvSpPr>
-          <p:cNvPr id="23" name="Shape 21"/>
-          <p:cNvSpPr/>
-          <p:nvPr/>
-        </p:nvSpPr>
-        <p:spPr>
-          <a:xfrm>
-            <a:off x="822960" y="5852160"/>
-            <a:ext cx="10515600" cy="685800"/>
+          <p:cNvPr id="20" name="Shape 18"/>
+          <p:cNvSpPr/>
+          <p:nvPr/>
+        </p:nvSpPr>
+        <p:spPr>
+          <a:xfrm>
+            <a:off x="822960" y="5989320"/>
+            <a:ext cx="10515600" cy="640080"/>
           </a:xfrm>
           <a:prstGeom prst="roundRect">
             <a:avLst>
-              <a:gd name="adj" fmla="val 46667"/>
+              <a:gd name="adj" fmla="val 50000"/>
             </a:avLst>
           </a:prstGeom>
           <a:solidFill>
@@ -3436,14 +3536,14 @@
       </p:sp>
       <p:sp>
         <p:nvSpPr>
-          <p:cNvPr id="24" name="Text 22"/>
-          <p:cNvSpPr/>
-          <p:nvPr/>
-        </p:nvSpPr>
-        <p:spPr>
-          <a:xfrm>
-            <a:off x="822960" y="5852160"/>
-            <a:ext cx="10515600" cy="685800"/>
+          <p:cNvPr id="21" name="Text 19"/>
+          <p:cNvSpPr/>
+          <p:nvPr/>
+        </p:nvSpPr>
+        <p:spPr>
+          <a:xfrm>
+            <a:off x="822960" y="5989320"/>
+            <a:ext cx="10515600" cy="640080"/>
           </a:xfrm>
           <a:prstGeom prst="rect">
             <a:avLst/>
@@ -3467,7 +3567,7 @@
                 <a:ea typeface="Calibri" pitchFamily="34" charset="-122"/>
                 <a:cs typeface="Calibri" pitchFamily="34" charset="-120"/>
               </a:rPr>
-              <a:t>Domain charge is not included in the Rs 50,000 — you pay the registrar directly, no markup.</a:t>
+              <a:t>Main promise: you hand us your school, we deliver a ready-to-use website with its complete visual kit.</a:t>
             </a:r>
             <a:endParaRPr lang="en-US" sz="1400" dirty="0"/>
           </a:p>
@@ -3484,6 +3584,965 @@
 <file path=ppt/slides/slide4.xml><?xml version="1.0" encoding="utf-8"?>
 <p:sld xmlns:a="http://schemas.openxmlformats.org/drawingml/2006/main" xmlns:r="http://schemas.openxmlformats.org/officeDocument/2006/relationships" xmlns:p="http://schemas.openxmlformats.org/presentationml/2006/main">
   <p:cSld name="Slide 4">
+    <p:bg>
+      <p:bgPr>
+        <a:solidFill>
+          <a:srgbClr val="FFFFFF"/>
+        </a:solidFill>
+      </p:bgPr>
+    </p:bg>
+    <p:spTree>
+      <p:nvGrpSpPr>
+        <p:cNvPr id="1" name=""/>
+        <p:cNvGrpSpPr/>
+        <p:nvPr/>
+      </p:nvGrpSpPr>
+      <p:grpSpPr>
+        <a:xfrm>
+          <a:off x="0" y="0"/>
+          <a:ext cx="0" cy="0"/>
+          <a:chOff x="0" y="0"/>
+          <a:chExt cx="0" cy="0"/>
+        </a:xfrm>
+      </p:grpSpPr>
+      <p:sp>
+        <p:nvSpPr>
+          <p:cNvPr id="2" name="Text 0"/>
+          <p:cNvSpPr/>
+          <p:nvPr/>
+        </p:nvSpPr>
+        <p:spPr>
+          <a:xfrm>
+            <a:off x="731520" y="457200"/>
+            <a:ext cx="7315200" cy="731520"/>
+          </a:xfrm>
+          <a:prstGeom prst="rect">
+            <a:avLst/>
+          </a:prstGeom>
+          <a:noFill/>
+          <a:ln/>
+        </p:spPr>
+        <p:txBody>
+          <a:bodyPr wrap="square" rtlCol="0" anchor="ctr"/>
+          <a:lstStyle/>
+          <a:p>
+            <a:pPr indent="0" marL="0">
+              <a:buNone/>
+            </a:pPr>
+            <a:r>
+              <a:rPr lang="en-US" sz="3000" b="1" dirty="0">
+                <a:solidFill>
+                  <a:srgbClr val="6F2DBD"/>
+                </a:solidFill>
+                <a:latin typeface="Trebuchet MS" pitchFamily="34" charset="0"/>
+                <a:ea typeface="Trebuchet MS" pitchFamily="34" charset="-122"/>
+                <a:cs typeface="Trebuchet MS" pitchFamily="34" charset="-120"/>
+              </a:rPr>
+              <a:t>Pricing &amp; terms</a:t>
+            </a:r>
+            <a:endParaRPr lang="en-US" sz="3000" dirty="0"/>
+          </a:p>
+        </p:txBody>
+      </p:sp>
+      <p:sp>
+        <p:nvSpPr>
+          <p:cNvPr id="3" name="Shape 1"/>
+          <p:cNvSpPr/>
+          <p:nvPr/>
+        </p:nvSpPr>
+        <p:spPr>
+          <a:xfrm>
+            <a:off x="822960" y="1280160"/>
+            <a:ext cx="3108960" cy="640080"/>
+          </a:xfrm>
+          <a:prstGeom prst="rect">
+            <a:avLst/>
+          </a:prstGeom>
+          <a:solidFill>
+            <a:srgbClr val="F3EDFB"/>
+          </a:solidFill>
+          <a:ln/>
+        </p:spPr>
+      </p:sp>
+      <p:sp>
+        <p:nvSpPr>
+          <p:cNvPr id="4" name="Text 2"/>
+          <p:cNvSpPr/>
+          <p:nvPr/>
+        </p:nvSpPr>
+        <p:spPr>
+          <a:xfrm>
+            <a:off x="822960" y="1280160"/>
+            <a:ext cx="3108960" cy="640080"/>
+          </a:xfrm>
+          <a:prstGeom prst="rect">
+            <a:avLst/>
+          </a:prstGeom>
+          <a:noFill/>
+          <a:ln/>
+        </p:spPr>
+        <p:txBody>
+          <a:bodyPr wrap="square" rtlCol="0" anchor="ctr"/>
+          <a:lstStyle/>
+          <a:p>
+            <a:pPr algn="ctr" indent="0" marL="0">
+              <a:buNone/>
+            </a:pPr>
+            <a:r>
+              <a:rPr lang="en-US" sz="1350" b="1" dirty="0">
+                <a:solidFill>
+                  <a:srgbClr val="6F2DBD"/>
+                </a:solidFill>
+                <a:latin typeface="Trebuchet MS" pitchFamily="34" charset="0"/>
+                <a:ea typeface="Trebuchet MS" pitchFamily="34" charset="-122"/>
+                <a:cs typeface="Trebuchet MS" pitchFamily="34" charset="-120"/>
+              </a:rPr>
+              <a:t>Website build</a:t>
+            </a:r>
+            <a:endParaRPr lang="en-US" sz="1350" dirty="0"/>
+          </a:p>
+        </p:txBody>
+      </p:sp>
+      <p:sp>
+        <p:nvSpPr>
+          <p:cNvPr id="5" name="Text 3"/>
+          <p:cNvSpPr/>
+          <p:nvPr/>
+        </p:nvSpPr>
+        <p:spPr>
+          <a:xfrm>
+            <a:off x="4114800" y="1280160"/>
+            <a:ext cx="2926080" cy="640080"/>
+          </a:xfrm>
+          <a:prstGeom prst="rect">
+            <a:avLst/>
+          </a:prstGeom>
+          <a:noFill/>
+          <a:ln/>
+        </p:spPr>
+        <p:txBody>
+          <a:bodyPr wrap="square" rtlCol="0" anchor="ctr"/>
+          <a:lstStyle/>
+          <a:p>
+            <a:pPr indent="0" marL="0">
+              <a:buNone/>
+            </a:pPr>
+            <a:r>
+              <a:rPr lang="en-US" sz="1450" b="1" dirty="0">
+                <a:solidFill>
+                  <a:srgbClr val="3A2E29"/>
+                </a:solidFill>
+                <a:latin typeface="Trebuchet MS" pitchFamily="34" charset="0"/>
+                <a:ea typeface="Trebuchet MS" pitchFamily="34" charset="-122"/>
+                <a:cs typeface="Trebuchet MS" pitchFamily="34" charset="-120"/>
+              </a:rPr>
+              <a:t>Rs 50,000</a:t>
+            </a:r>
+            <a:endParaRPr lang="en-US" sz="1450" dirty="0"/>
+          </a:p>
+        </p:txBody>
+      </p:sp>
+      <p:sp>
+        <p:nvSpPr>
+          <p:cNvPr id="6" name="Text 4"/>
+          <p:cNvSpPr/>
+          <p:nvPr/>
+        </p:nvSpPr>
+        <p:spPr>
+          <a:xfrm>
+            <a:off x="7223760" y="1280160"/>
+            <a:ext cx="4206240" cy="640080"/>
+          </a:xfrm>
+          <a:prstGeom prst="rect">
+            <a:avLst/>
+          </a:prstGeom>
+          <a:noFill/>
+          <a:ln/>
+        </p:spPr>
+        <p:txBody>
+          <a:bodyPr wrap="square" rtlCol="0" anchor="ctr"/>
+          <a:lstStyle/>
+          <a:p>
+            <a:pPr indent="0" marL="0">
+              <a:buNone/>
+            </a:pPr>
+            <a:r>
+              <a:rPr lang="en-US" dirty="0">
+                <a:solidFill>
+                  <a:srgbClr val="725A4A"/>
+                </a:solidFill>
+                <a:latin typeface="Calibri" pitchFamily="34" charset="0"/>
+                <a:ea typeface="Calibri" pitchFamily="34" charset="-122"/>
+                <a:cs typeface="Calibri" pitchFamily="34" charset="-120"/>
+              </a:rPr>
+              <a:t>Design, development, testing, deploy</a:t>
+            </a:r>
+            <a:endParaRPr lang="en-US" dirty="0"/>
+          </a:p>
+        </p:txBody>
+      </p:sp>
+      <p:sp>
+        <p:nvSpPr>
+          <p:cNvPr id="7" name="Shape 5"/>
+          <p:cNvSpPr/>
+          <p:nvPr/>
+        </p:nvSpPr>
+        <p:spPr>
+          <a:xfrm>
+            <a:off x="822960" y="2029968"/>
+            <a:ext cx="3108960" cy="640080"/>
+          </a:xfrm>
+          <a:prstGeom prst="rect">
+            <a:avLst/>
+          </a:prstGeom>
+          <a:solidFill>
+            <a:srgbClr val="F3EDFB"/>
+          </a:solidFill>
+          <a:ln/>
+        </p:spPr>
+      </p:sp>
+      <p:sp>
+        <p:nvSpPr>
+          <p:cNvPr id="8" name="Text 6"/>
+          <p:cNvSpPr/>
+          <p:nvPr/>
+        </p:nvSpPr>
+        <p:spPr>
+          <a:xfrm>
+            <a:off x="822960" y="2029968"/>
+            <a:ext cx="3108960" cy="640080"/>
+          </a:xfrm>
+          <a:prstGeom prst="rect">
+            <a:avLst/>
+          </a:prstGeom>
+          <a:noFill/>
+          <a:ln/>
+        </p:spPr>
+        <p:txBody>
+          <a:bodyPr wrap="square" rtlCol="0" anchor="ctr"/>
+          <a:lstStyle/>
+          <a:p>
+            <a:pPr algn="ctr" indent="0" marL="0">
+              <a:buNone/>
+            </a:pPr>
+            <a:r>
+              <a:rPr lang="en-US" sz="1350" b="1" dirty="0">
+                <a:solidFill>
+                  <a:srgbClr val="6F2DBD"/>
+                </a:solidFill>
+                <a:latin typeface="Trebuchet MS" pitchFamily="34" charset="0"/>
+                <a:ea typeface="Trebuchet MS" pitchFamily="34" charset="-122"/>
+                <a:cs typeface="Trebuchet MS" pitchFamily="34" charset="-120"/>
+              </a:rPr>
+              <a:t>Additional designs</a:t>
+            </a:r>
+            <a:endParaRPr lang="en-US" sz="1350" dirty="0"/>
+          </a:p>
+        </p:txBody>
+      </p:sp>
+      <p:sp>
+        <p:nvSpPr>
+          <p:cNvPr id="9" name="Text 7"/>
+          <p:cNvSpPr/>
+          <p:nvPr/>
+        </p:nvSpPr>
+        <p:spPr>
+          <a:xfrm>
+            <a:off x="4114800" y="2029968"/>
+            <a:ext cx="2926080" cy="640080"/>
+          </a:xfrm>
+          <a:prstGeom prst="rect">
+            <a:avLst/>
+          </a:prstGeom>
+          <a:noFill/>
+          <a:ln/>
+        </p:spPr>
+        <p:txBody>
+          <a:bodyPr wrap="square" rtlCol="0" anchor="ctr"/>
+          <a:lstStyle/>
+          <a:p>
+            <a:pPr indent="0" marL="0">
+              <a:buNone/>
+            </a:pPr>
+            <a:r>
+              <a:rPr lang="en-US" sz="1450" b="1" dirty="0">
+                <a:solidFill>
+                  <a:srgbClr val="3A2E29"/>
+                </a:solidFill>
+                <a:latin typeface="Trebuchet MS" pitchFamily="34" charset="0"/>
+                <a:ea typeface="Trebuchet MS" pitchFamily="34" charset="-122"/>
+                <a:cs typeface="Trebuchet MS" pitchFamily="34" charset="-120"/>
+              </a:rPr>
+              <a:t>Included</a:t>
+            </a:r>
+            <a:endParaRPr lang="en-US" sz="1450" dirty="0"/>
+          </a:p>
+        </p:txBody>
+      </p:sp>
+      <p:sp>
+        <p:nvSpPr>
+          <p:cNvPr id="10" name="Text 8"/>
+          <p:cNvSpPr/>
+          <p:nvPr/>
+        </p:nvSpPr>
+        <p:spPr>
+          <a:xfrm>
+            <a:off x="7223760" y="2029968"/>
+            <a:ext cx="4206240" cy="640080"/>
+          </a:xfrm>
+          <a:prstGeom prst="rect">
+            <a:avLst/>
+          </a:prstGeom>
+          <a:noFill/>
+          <a:ln/>
+        </p:spPr>
+        <p:txBody>
+          <a:bodyPr wrap="square" rtlCol="0" anchor="ctr"/>
+          <a:lstStyle/>
+          <a:p>
+            <a:pPr indent="0" marL="0">
+              <a:buNone/>
+            </a:pPr>
+            <a:r>
+              <a:rPr lang="en-US" dirty="0">
+                <a:solidFill>
+                  <a:srgbClr val="725A4A"/>
+                </a:solidFill>
+                <a:latin typeface="Calibri" pitchFamily="34" charset="0"/>
+                <a:ea typeface="Calibri" pitchFamily="34" charset="-122"/>
+                <a:cs typeface="Calibri" pitchFamily="34" charset="-120"/>
+              </a:rPr>
+              <a:t>Logo, banners, icons, social graphics for the site</a:t>
+            </a:r>
+            <a:endParaRPr lang="en-US" dirty="0"/>
+          </a:p>
+        </p:txBody>
+      </p:sp>
+      <p:sp>
+        <p:nvSpPr>
+          <p:cNvPr id="11" name="Shape 9"/>
+          <p:cNvSpPr/>
+          <p:nvPr/>
+        </p:nvSpPr>
+        <p:spPr>
+          <a:xfrm>
+            <a:off x="822960" y="2779776"/>
+            <a:ext cx="3108960" cy="640080"/>
+          </a:xfrm>
+          <a:prstGeom prst="rect">
+            <a:avLst/>
+          </a:prstGeom>
+          <a:solidFill>
+            <a:srgbClr val="F3EDFB"/>
+          </a:solidFill>
+          <a:ln/>
+        </p:spPr>
+      </p:sp>
+      <p:sp>
+        <p:nvSpPr>
+          <p:cNvPr id="12" name="Text 10"/>
+          <p:cNvSpPr/>
+          <p:nvPr/>
+        </p:nvSpPr>
+        <p:spPr>
+          <a:xfrm>
+            <a:off x="822960" y="2779776"/>
+            <a:ext cx="3108960" cy="640080"/>
+          </a:xfrm>
+          <a:prstGeom prst="rect">
+            <a:avLst/>
+          </a:prstGeom>
+          <a:noFill/>
+          <a:ln/>
+        </p:spPr>
+        <p:txBody>
+          <a:bodyPr wrap="square" rtlCol="0" anchor="ctr"/>
+          <a:lstStyle/>
+          <a:p>
+            <a:pPr algn="ctr" indent="0" marL="0">
+              <a:buNone/>
+            </a:pPr>
+            <a:r>
+              <a:rPr lang="en-US" sz="1350" b="1" dirty="0">
+                <a:solidFill>
+                  <a:srgbClr val="6F2DBD"/>
+                </a:solidFill>
+                <a:latin typeface="Trebuchet MS" pitchFamily="34" charset="0"/>
+                <a:ea typeface="Trebuchet MS" pitchFamily="34" charset="-122"/>
+                <a:cs typeface="Trebuchet MS" pitchFamily="34" charset="-120"/>
+              </a:rPr>
+              <a:t>Domain</a:t>
+            </a:r>
+            <a:endParaRPr lang="en-US" sz="1350" dirty="0"/>
+          </a:p>
+        </p:txBody>
+      </p:sp>
+      <p:sp>
+        <p:nvSpPr>
+          <p:cNvPr id="13" name="Text 11"/>
+          <p:cNvSpPr/>
+          <p:nvPr/>
+        </p:nvSpPr>
+        <p:spPr>
+          <a:xfrm>
+            <a:off x="4114800" y="2779776"/>
+            <a:ext cx="2926080" cy="640080"/>
+          </a:xfrm>
+          <a:prstGeom prst="rect">
+            <a:avLst/>
+          </a:prstGeom>
+          <a:noFill/>
+          <a:ln/>
+        </p:spPr>
+        <p:txBody>
+          <a:bodyPr wrap="square" rtlCol="0" anchor="ctr"/>
+          <a:lstStyle/>
+          <a:p>
+            <a:pPr indent="0" marL="0">
+              <a:buNone/>
+            </a:pPr>
+            <a:r>
+              <a:rPr lang="en-US" sz="1450" b="1" dirty="0">
+                <a:solidFill>
+                  <a:srgbClr val="3A2E29"/>
+                </a:solidFill>
+                <a:latin typeface="Trebuchet MS" pitchFamily="34" charset="0"/>
+                <a:ea typeface="Trebuchet MS" pitchFamily="34" charset="-122"/>
+                <a:cs typeface="Trebuchet MS" pitchFamily="34" charset="-120"/>
+              </a:rPr>
+              <a:t>Actual cost</a:t>
+            </a:r>
+            <a:endParaRPr lang="en-US" sz="1450" dirty="0"/>
+          </a:p>
+        </p:txBody>
+      </p:sp>
+      <p:sp>
+        <p:nvSpPr>
+          <p:cNvPr id="14" name="Text 12"/>
+          <p:cNvSpPr/>
+          <p:nvPr/>
+        </p:nvSpPr>
+        <p:spPr>
+          <a:xfrm>
+            <a:off x="7223760" y="2779776"/>
+            <a:ext cx="4206240" cy="640080"/>
+          </a:xfrm>
+          <a:prstGeom prst="rect">
+            <a:avLst/>
+          </a:prstGeom>
+          <a:noFill/>
+          <a:ln/>
+        </p:spPr>
+        <p:txBody>
+          <a:bodyPr wrap="square" rtlCol="0" anchor="ctr"/>
+          <a:lstStyle/>
+          <a:p>
+            <a:pPr indent="0" marL="0">
+              <a:buNone/>
+            </a:pPr>
+            <a:r>
+              <a:rPr lang="en-US" dirty="0">
+                <a:solidFill>
+                  <a:srgbClr val="725A4A"/>
+                </a:solidFill>
+                <a:latin typeface="Calibri" pitchFamily="34" charset="0"/>
+                <a:ea typeface="Calibri" pitchFamily="34" charset="-122"/>
+                <a:cs typeface="Calibri" pitchFamily="34" charset="-120"/>
+              </a:rPr>
+              <a:t>Billed directly by the registrar (e.g. .in or .com)</a:t>
+            </a:r>
+            <a:endParaRPr lang="en-US" dirty="0"/>
+          </a:p>
+        </p:txBody>
+      </p:sp>
+      <p:sp>
+        <p:nvSpPr>
+          <p:cNvPr id="15" name="Shape 13"/>
+          <p:cNvSpPr/>
+          <p:nvPr/>
+        </p:nvSpPr>
+        <p:spPr>
+          <a:xfrm>
+            <a:off x="822960" y="3529584"/>
+            <a:ext cx="3108960" cy="640080"/>
+          </a:xfrm>
+          <a:prstGeom prst="rect">
+            <a:avLst/>
+          </a:prstGeom>
+          <a:solidFill>
+            <a:srgbClr val="F3EDFB"/>
+          </a:solidFill>
+          <a:ln/>
+        </p:spPr>
+      </p:sp>
+      <p:sp>
+        <p:nvSpPr>
+          <p:cNvPr id="16" name="Text 14"/>
+          <p:cNvSpPr/>
+          <p:nvPr/>
+        </p:nvSpPr>
+        <p:spPr>
+          <a:xfrm>
+            <a:off x="822960" y="3529584"/>
+            <a:ext cx="3108960" cy="640080"/>
+          </a:xfrm>
+          <a:prstGeom prst="rect">
+            <a:avLst/>
+          </a:prstGeom>
+          <a:noFill/>
+          <a:ln/>
+        </p:spPr>
+        <p:txBody>
+          <a:bodyPr wrap="square" rtlCol="0" anchor="ctr"/>
+          <a:lstStyle/>
+          <a:p>
+            <a:pPr algn="ctr" indent="0" marL="0">
+              <a:buNone/>
+            </a:pPr>
+            <a:r>
+              <a:rPr lang="en-US" sz="1350" b="1" dirty="0">
+                <a:solidFill>
+                  <a:srgbClr val="6F2DBD"/>
+                </a:solidFill>
+                <a:latin typeface="Trebuchet MS" pitchFamily="34" charset="0"/>
+                <a:ea typeface="Trebuchet MS" pitchFamily="34" charset="-122"/>
+                <a:cs typeface="Trebuchet MS" pitchFamily="34" charset="-120"/>
+              </a:rPr>
+              <a:t>Hosting</a:t>
+            </a:r>
+            <a:endParaRPr lang="en-US" sz="1350" dirty="0"/>
+          </a:p>
+        </p:txBody>
+      </p:sp>
+      <p:sp>
+        <p:nvSpPr>
+          <p:cNvPr id="17" name="Text 15"/>
+          <p:cNvSpPr/>
+          <p:nvPr/>
+        </p:nvSpPr>
+        <p:spPr>
+          <a:xfrm>
+            <a:off x="4114800" y="3529584"/>
+            <a:ext cx="2926080" cy="640080"/>
+          </a:xfrm>
+          <a:prstGeom prst="rect">
+            <a:avLst/>
+          </a:prstGeom>
+          <a:noFill/>
+          <a:ln/>
+        </p:spPr>
+        <p:txBody>
+          <a:bodyPr wrap="square" rtlCol="0" anchor="ctr"/>
+          <a:lstStyle/>
+          <a:p>
+            <a:pPr indent="0" marL="0">
+              <a:buNone/>
+            </a:pPr>
+            <a:r>
+              <a:rPr lang="en-US" sz="1450" b="1" dirty="0">
+                <a:solidFill>
+                  <a:srgbClr val="3A2E29"/>
+                </a:solidFill>
+                <a:latin typeface="Trebuchet MS" pitchFamily="34" charset="0"/>
+                <a:ea typeface="Trebuchet MS" pitchFamily="34" charset="-122"/>
+                <a:cs typeface="Trebuchet MS" pitchFamily="34" charset="-120"/>
+              </a:rPr>
+              <a:t>Included first year</a:t>
+            </a:r>
+            <a:endParaRPr lang="en-US" sz="1450" dirty="0"/>
+          </a:p>
+        </p:txBody>
+      </p:sp>
+      <p:sp>
+        <p:nvSpPr>
+          <p:cNvPr id="18" name="Text 16"/>
+          <p:cNvSpPr/>
+          <p:nvPr/>
+        </p:nvSpPr>
+        <p:spPr>
+          <a:xfrm>
+            <a:off x="7223760" y="3529584"/>
+            <a:ext cx="4206240" cy="640080"/>
+          </a:xfrm>
+          <a:prstGeom prst="rect">
+            <a:avLst/>
+          </a:prstGeom>
+          <a:noFill/>
+          <a:ln/>
+        </p:spPr>
+        <p:txBody>
+          <a:bodyPr wrap="square" rtlCol="0" anchor="ctr"/>
+          <a:lstStyle/>
+          <a:p>
+            <a:pPr indent="0" marL="0">
+              <a:buNone/>
+            </a:pPr>
+            <a:r>
+              <a:rPr lang="en-US" dirty="0">
+                <a:solidFill>
+                  <a:srgbClr val="725A4A"/>
+                </a:solidFill>
+                <a:latin typeface="Calibri" pitchFamily="34" charset="0"/>
+                <a:ea typeface="Calibri" pitchFamily="34" charset="-122"/>
+                <a:cs typeface="Calibri" pitchFamily="34" charset="-120"/>
+              </a:rPr>
+              <a:t>Fast, secure hosting on our platform</a:t>
+            </a:r>
+            <a:endParaRPr lang="en-US" dirty="0"/>
+          </a:p>
+        </p:txBody>
+      </p:sp>
+      <p:sp>
+        <p:nvSpPr>
+          <p:cNvPr id="19" name="Shape 17"/>
+          <p:cNvSpPr/>
+          <p:nvPr/>
+        </p:nvSpPr>
+        <p:spPr>
+          <a:xfrm>
+            <a:off x="822960" y="4279392"/>
+            <a:ext cx="3108960" cy="640080"/>
+          </a:xfrm>
+          <a:prstGeom prst="rect">
+            <a:avLst/>
+          </a:prstGeom>
+          <a:solidFill>
+            <a:srgbClr val="F3EDFB"/>
+          </a:solidFill>
+          <a:ln/>
+        </p:spPr>
+      </p:sp>
+      <p:sp>
+        <p:nvSpPr>
+          <p:cNvPr id="20" name="Text 18"/>
+          <p:cNvSpPr/>
+          <p:nvPr/>
+        </p:nvSpPr>
+        <p:spPr>
+          <a:xfrm>
+            <a:off x="822960" y="4279392"/>
+            <a:ext cx="3108960" cy="640080"/>
+          </a:xfrm>
+          <a:prstGeom prst="rect">
+            <a:avLst/>
+          </a:prstGeom>
+          <a:noFill/>
+          <a:ln/>
+        </p:spPr>
+        <p:txBody>
+          <a:bodyPr wrap="square" rtlCol="0" anchor="ctr"/>
+          <a:lstStyle/>
+          <a:p>
+            <a:pPr algn="ctr" indent="0" marL="0">
+              <a:buNone/>
+            </a:pPr>
+            <a:r>
+              <a:rPr lang="en-US" sz="1350" b="1" dirty="0">
+                <a:solidFill>
+                  <a:srgbClr val="6F2DBD"/>
+                </a:solidFill>
+                <a:latin typeface="Trebuchet MS" pitchFamily="34" charset="0"/>
+                <a:ea typeface="Trebuchet MS" pitchFamily="34" charset="-122"/>
+                <a:cs typeface="Trebuchet MS" pitchFamily="34" charset="-120"/>
+              </a:rPr>
+              <a:t>Support</a:t>
+            </a:r>
+            <a:endParaRPr lang="en-US" sz="1350" dirty="0"/>
+          </a:p>
+        </p:txBody>
+      </p:sp>
+      <p:sp>
+        <p:nvSpPr>
+          <p:cNvPr id="21" name="Text 19"/>
+          <p:cNvSpPr/>
+          <p:nvPr/>
+        </p:nvSpPr>
+        <p:spPr>
+          <a:xfrm>
+            <a:off x="4114800" y="4279392"/>
+            <a:ext cx="2926080" cy="640080"/>
+          </a:xfrm>
+          <a:prstGeom prst="rect">
+            <a:avLst/>
+          </a:prstGeom>
+          <a:noFill/>
+          <a:ln/>
+        </p:spPr>
+        <p:txBody>
+          <a:bodyPr wrap="square" rtlCol="0" anchor="ctr"/>
+          <a:lstStyle/>
+          <a:p>
+            <a:pPr indent="0" marL="0">
+              <a:buNone/>
+            </a:pPr>
+            <a:r>
+              <a:rPr lang="en-US" sz="1450" b="1" dirty="0">
+                <a:solidFill>
+                  <a:srgbClr val="3A2E29"/>
+                </a:solidFill>
+                <a:latin typeface="Trebuchet MS" pitchFamily="34" charset="0"/>
+                <a:ea typeface="Trebuchet MS" pitchFamily="34" charset="-122"/>
+                <a:cs typeface="Trebuchet MS" pitchFamily="34" charset="-120"/>
+              </a:rPr>
+              <a:t>3 months</a:t>
+            </a:r>
+            <a:endParaRPr lang="en-US" sz="1450" dirty="0"/>
+          </a:p>
+        </p:txBody>
+      </p:sp>
+      <p:sp>
+        <p:nvSpPr>
+          <p:cNvPr id="22" name="Text 20"/>
+          <p:cNvSpPr/>
+          <p:nvPr/>
+        </p:nvSpPr>
+        <p:spPr>
+          <a:xfrm>
+            <a:off x="7223760" y="4279392"/>
+            <a:ext cx="4206240" cy="640080"/>
+          </a:xfrm>
+          <a:prstGeom prst="rect">
+            <a:avLst/>
+          </a:prstGeom>
+          <a:noFill/>
+          <a:ln/>
+        </p:spPr>
+        <p:txBody>
+          <a:bodyPr wrap="square" rtlCol="0" anchor="ctr"/>
+          <a:lstStyle/>
+          <a:p>
+            <a:pPr indent="0" marL="0">
+              <a:buNone/>
+            </a:pPr>
+            <a:r>
+              <a:rPr lang="en-US" dirty="0">
+                <a:solidFill>
+                  <a:srgbClr val="725A4A"/>
+                </a:solidFill>
+                <a:latin typeface="Calibri" pitchFamily="34" charset="0"/>
+                <a:ea typeface="Calibri" pitchFamily="34" charset="-122"/>
+                <a:cs typeface="Calibri" pitchFamily="34" charset="-120"/>
+              </a:rPr>
+              <a:t>Issues resolved free for 3 months after launch</a:t>
+            </a:r>
+            <a:endParaRPr lang="en-US" dirty="0"/>
+          </a:p>
+        </p:txBody>
+      </p:sp>
+      <p:sp>
+        <p:nvSpPr>
+          <p:cNvPr id="23" name="Shape 21"/>
+          <p:cNvSpPr/>
+          <p:nvPr/>
+        </p:nvSpPr>
+        <p:spPr>
+          <a:xfrm>
+            <a:off x="822960" y="5029200"/>
+            <a:ext cx="3108960" cy="640080"/>
+          </a:xfrm>
+          <a:prstGeom prst="rect">
+            <a:avLst/>
+          </a:prstGeom>
+          <a:solidFill>
+            <a:srgbClr val="F3EDFB"/>
+          </a:solidFill>
+          <a:ln/>
+        </p:spPr>
+      </p:sp>
+      <p:sp>
+        <p:nvSpPr>
+          <p:cNvPr id="24" name="Text 22"/>
+          <p:cNvSpPr/>
+          <p:nvPr/>
+        </p:nvSpPr>
+        <p:spPr>
+          <a:xfrm>
+            <a:off x="822960" y="5029200"/>
+            <a:ext cx="3108960" cy="640080"/>
+          </a:xfrm>
+          <a:prstGeom prst="rect">
+            <a:avLst/>
+          </a:prstGeom>
+          <a:noFill/>
+          <a:ln/>
+        </p:spPr>
+        <p:txBody>
+          <a:bodyPr wrap="square" rtlCol="0" anchor="ctr"/>
+          <a:lstStyle/>
+          <a:p>
+            <a:pPr algn="ctr" indent="0" marL="0">
+              <a:buNone/>
+            </a:pPr>
+            <a:r>
+              <a:rPr lang="en-US" sz="1350" b="1" dirty="0">
+                <a:solidFill>
+                  <a:srgbClr val="6F2DBD"/>
+                </a:solidFill>
+                <a:latin typeface="Trebuchet MS" pitchFamily="34" charset="0"/>
+                <a:ea typeface="Trebuchet MS" pitchFamily="34" charset="-122"/>
+                <a:cs typeface="Trebuchet MS" pitchFamily="34" charset="-120"/>
+              </a:rPr>
+              <a:t>Timeline</a:t>
+            </a:r>
+            <a:endParaRPr lang="en-US" sz="1350" dirty="0"/>
+          </a:p>
+        </p:txBody>
+      </p:sp>
+      <p:sp>
+        <p:nvSpPr>
+          <p:cNvPr id="25" name="Text 23"/>
+          <p:cNvSpPr/>
+          <p:nvPr/>
+        </p:nvSpPr>
+        <p:spPr>
+          <a:xfrm>
+            <a:off x="4114800" y="5029200"/>
+            <a:ext cx="2926080" cy="640080"/>
+          </a:xfrm>
+          <a:prstGeom prst="rect">
+            <a:avLst/>
+          </a:prstGeom>
+          <a:noFill/>
+          <a:ln/>
+        </p:spPr>
+        <p:txBody>
+          <a:bodyPr wrap="square" rtlCol="0" anchor="ctr"/>
+          <a:lstStyle/>
+          <a:p>
+            <a:pPr indent="0" marL="0">
+              <a:buNone/>
+            </a:pPr>
+            <a:r>
+              <a:rPr lang="en-US" sz="1450" b="1" dirty="0">
+                <a:solidFill>
+                  <a:srgbClr val="3A2E29"/>
+                </a:solidFill>
+                <a:latin typeface="Trebuchet MS" pitchFamily="34" charset="0"/>
+                <a:ea typeface="Trebuchet MS" pitchFamily="34" charset="-122"/>
+                <a:cs typeface="Trebuchet MS" pitchFamily="34" charset="-120"/>
+              </a:rPr>
+              <a:t>4–6 weeks</a:t>
+            </a:r>
+            <a:endParaRPr lang="en-US" sz="1450" dirty="0"/>
+          </a:p>
+        </p:txBody>
+      </p:sp>
+      <p:sp>
+        <p:nvSpPr>
+          <p:cNvPr id="26" name="Text 24"/>
+          <p:cNvSpPr/>
+          <p:nvPr/>
+        </p:nvSpPr>
+        <p:spPr>
+          <a:xfrm>
+            <a:off x="7223760" y="5029200"/>
+            <a:ext cx="4206240" cy="640080"/>
+          </a:xfrm>
+          <a:prstGeom prst="rect">
+            <a:avLst/>
+          </a:prstGeom>
+          <a:noFill/>
+          <a:ln/>
+        </p:spPr>
+        <p:txBody>
+          <a:bodyPr wrap="square" rtlCol="0" anchor="ctr"/>
+          <a:lstStyle/>
+          <a:p>
+            <a:pPr indent="0" marL="0">
+              <a:buNone/>
+            </a:pPr>
+            <a:r>
+              <a:rPr lang="en-US" dirty="0">
+                <a:solidFill>
+                  <a:srgbClr val="725A4A"/>
+                </a:solidFill>
+                <a:latin typeface="Calibri" pitchFamily="34" charset="0"/>
+                <a:ea typeface="Calibri" pitchFamily="34" charset="-122"/>
+                <a:cs typeface="Calibri" pitchFamily="34" charset="-120"/>
+              </a:rPr>
+              <a:t>From content handover to live site</a:t>
+            </a:r>
+            <a:endParaRPr lang="en-US" dirty="0"/>
+          </a:p>
+        </p:txBody>
+      </p:sp>
+      <p:sp>
+        <p:nvSpPr>
+          <p:cNvPr id="27" name="Shape 25"/>
+          <p:cNvSpPr/>
+          <p:nvPr/>
+        </p:nvSpPr>
+        <p:spPr>
+          <a:xfrm>
+            <a:off x="822960" y="5852160"/>
+            <a:ext cx="10515600" cy="685800"/>
+          </a:xfrm>
+          <a:prstGeom prst="roundRect">
+            <a:avLst>
+              <a:gd name="adj" fmla="val 46667"/>
+            </a:avLst>
+          </a:prstGeom>
+          <a:solidFill>
+            <a:srgbClr val="FFC53D"/>
+          </a:solidFill>
+          <a:ln w="12700">
+            <a:solidFill>
+              <a:srgbClr val="FFC53D"/>
+            </a:solidFill>
+            <a:prstDash val="solid"/>
+          </a:ln>
+        </p:spPr>
+      </p:sp>
+      <p:sp>
+        <p:nvSpPr>
+          <p:cNvPr id="28" name="Text 26"/>
+          <p:cNvSpPr/>
+          <p:nvPr/>
+        </p:nvSpPr>
+        <p:spPr>
+          <a:xfrm>
+            <a:off x="822960" y="5852160"/>
+            <a:ext cx="10515600" cy="685800"/>
+          </a:xfrm>
+          <a:prstGeom prst="rect">
+            <a:avLst/>
+          </a:prstGeom>
+          <a:noFill/>
+          <a:ln/>
+        </p:spPr>
+        <p:txBody>
+          <a:bodyPr wrap="square" rtlCol="0" anchor="ctr"/>
+          <a:lstStyle/>
+          <a:p>
+            <a:pPr algn="ctr" indent="0" marL="0">
+              <a:buNone/>
+            </a:pPr>
+            <a:r>
+              <a:rPr lang="en-US" sz="1400" b="1" dirty="0">
+                <a:solidFill>
+                  <a:srgbClr val="3A2E29"/>
+                </a:solidFill>
+                <a:latin typeface="Calibri" pitchFamily="34" charset="0"/>
+                <a:ea typeface="Calibri" pitchFamily="34" charset="-122"/>
+                <a:cs typeface="Calibri" pitchFamily="34" charset="-120"/>
+              </a:rPr>
+              <a:t>Domain charge is not included in the Rs 50,000 — you pay the registrar directly, no markup.</a:t>
+            </a:r>
+            <a:endParaRPr lang="en-US" sz="1400" dirty="0"/>
+          </a:p>
+        </p:txBody>
+      </p:sp>
+    </p:spTree>
+  </p:cSld>
+  <p:clrMapOvr>
+    <a:masterClrMapping/>
+  </p:clrMapOvr>
+</p:sld>
+</file>
+
+<file path=ppt/slides/slide5.xml><?xml version="1.0" encoding="utf-8"?>
+<p:sld xmlns:a="http://schemas.openxmlformats.org/drawingml/2006/main" xmlns:r="http://schemas.openxmlformats.org/officeDocument/2006/relationships" xmlns:p="http://schemas.openxmlformats.org/presentationml/2006/main">
+  <p:cSld name="Slide 5">
     <p:bg>
       <p:bgPr>
         <a:solidFill>
@@ -3646,7 +4705,7 @@
         <p:spPr>
           <a:xfrm>
             <a:off x="1691640" y="1865376"/>
-            <a:ext cx="2286000" cy="457200"/>
+            <a:ext cx="2560320" cy="457200"/>
           </a:xfrm>
           <a:prstGeom prst="rect">
             <a:avLst/>
@@ -3817,7 +4876,7 @@
         <p:spPr>
           <a:xfrm>
             <a:off x="5440680" y="1865376"/>
-            <a:ext cx="2286000" cy="457200"/>
+            <a:ext cx="2560320" cy="457200"/>
           </a:xfrm>
           <a:prstGeom prst="rect">
             <a:avLst/>
@@ -3841,7 +4900,7 @@
                 <a:ea typeface="Trebuchet MS" pitchFamily="34" charset="-122"/>
                 <a:cs typeface="Trebuchet MS" pitchFamily="34" charset="-120"/>
               </a:rPr>
-              <a:t>Design</a:t>
+              <a:t>Designs</a:t>
             </a:r>
             <a:endParaRPr lang="en-US" sz="1700" dirty="0"/>
           </a:p>
@@ -3880,7 +4939,7 @@
                 <a:ea typeface="Calibri" pitchFamily="34" charset="-122"/>
                 <a:cs typeface="Calibri" pitchFamily="34" charset="-120"/>
               </a:rPr>
-              <a:t>We design your site and confirm with you</a:t>
+              <a:t>We design logos, banners and site visuals for you</a:t>
             </a:r>
             <a:endParaRPr lang="en-US" sz="1250" dirty="0"/>
           </a:p>
@@ -3988,7 +5047,7 @@
         <p:spPr>
           <a:xfrm>
             <a:off x="9189720" y="1865376"/>
-            <a:ext cx="2286000" cy="457200"/>
+            <a:ext cx="2560320" cy="457200"/>
           </a:xfrm>
           <a:prstGeom prst="rect">
             <a:avLst/>
@@ -4159,7 +5218,7 @@
         <p:spPr>
           <a:xfrm>
             <a:off x="1691640" y="4425696"/>
-            <a:ext cx="2286000" cy="457200"/>
+            <a:ext cx="2560320" cy="457200"/>
           </a:xfrm>
           <a:prstGeom prst="rect">
             <a:avLst/>
@@ -4330,7 +5389,7 @@
         <p:spPr>
           <a:xfrm>
             <a:off x="5440680" y="4425696"/>
-            <a:ext cx="2286000" cy="457200"/>
+            <a:ext cx="2560320" cy="457200"/>
           </a:xfrm>
           <a:prstGeom prst="rect">
             <a:avLst/>
@@ -4407,9 +5466,577 @@
 </p:sld>
 </file>
 
-<file path=ppt/slides/slide5.xml><?xml version="1.0" encoding="utf-8"?>
+<file path=ppt/slides/slide6.xml><?xml version="1.0" encoding="utf-8"?>
 <p:sld xmlns:a="http://schemas.openxmlformats.org/drawingml/2006/main" xmlns:r="http://schemas.openxmlformats.org/officeDocument/2006/relationships" xmlns:p="http://schemas.openxmlformats.org/presentationml/2006/main">
-  <p:cSld name="Slide 5">
+  <p:cSld name="Slide 6">
+    <p:bg>
+      <p:bgPr>
+        <a:solidFill>
+          <a:srgbClr val="FFF6E0"/>
+        </a:solidFill>
+      </p:bgPr>
+    </p:bg>
+    <p:spTree>
+      <p:nvGrpSpPr>
+        <p:cNvPr id="1" name=""/>
+        <p:cNvGrpSpPr/>
+        <p:nvPr/>
+      </p:nvGrpSpPr>
+      <p:grpSpPr>
+        <a:xfrm>
+          <a:off x="0" y="0"/>
+          <a:ext cx="0" cy="0"/>
+          <a:chOff x="0" y="0"/>
+          <a:chExt cx="0" cy="0"/>
+        </a:xfrm>
+      </p:grpSpPr>
+      <p:sp>
+        <p:nvSpPr>
+          <p:cNvPr id="2" name="Text 0"/>
+          <p:cNvSpPr/>
+          <p:nvPr/>
+        </p:nvSpPr>
+        <p:spPr>
+          <a:xfrm>
+            <a:off x="731520" y="457200"/>
+            <a:ext cx="10058400" cy="731520"/>
+          </a:xfrm>
+          <a:prstGeom prst="rect">
+            <a:avLst/>
+          </a:prstGeom>
+          <a:noFill/>
+          <a:ln/>
+        </p:spPr>
+        <p:txBody>
+          <a:bodyPr wrap="square" rtlCol="0" anchor="ctr"/>
+          <a:lstStyle/>
+          <a:p>
+            <a:pPr indent="0" marL="0">
+              <a:buNone/>
+            </a:pPr>
+            <a:r>
+              <a:rPr lang="en-US" sz="3000" b="1" dirty="0">
+                <a:solidFill>
+                  <a:srgbClr val="6F2DBD"/>
+                </a:solidFill>
+                <a:latin typeface="Trebuchet MS" pitchFamily="34" charset="0"/>
+                <a:ea typeface="Trebuchet MS" pitchFamily="34" charset="-122"/>
+                <a:cs typeface="Trebuchet MS" pitchFamily="34" charset="-120"/>
+              </a:rPr>
+              <a:t>Self-managed option (full control)</a:t>
+            </a:r>
+            <a:endParaRPr lang="en-US" sz="3000" dirty="0"/>
+          </a:p>
+        </p:txBody>
+      </p:sp>
+      <p:sp>
+        <p:nvSpPr>
+          <p:cNvPr id="3" name="Text 1"/>
+          <p:cNvSpPr/>
+          <p:nvPr/>
+        </p:nvSpPr>
+        <p:spPr>
+          <a:xfrm>
+            <a:off x="731520" y="1188720"/>
+            <a:ext cx="10424160" cy="457200"/>
+          </a:xfrm>
+          <a:prstGeom prst="rect">
+            <a:avLst/>
+          </a:prstGeom>
+          <a:noFill/>
+          <a:ln/>
+        </p:spPr>
+        <p:txBody>
+          <a:bodyPr wrap="square" rtlCol="0" anchor="ctr"/>
+          <a:lstStyle/>
+          <a:p>
+            <a:pPr indent="0" marL="0">
+              <a:buNone/>
+            </a:pPr>
+            <a:r>
+              <a:rPr lang="en-US" dirty="0">
+                <a:solidFill>
+                  <a:srgbClr val="725A4A"/>
+                </a:solidFill>
+                <a:latin typeface="Calibri" pitchFamily="34" charset="0"/>
+                <a:ea typeface="Calibri" pitchFamily="34" charset="-122"/>
+                <a:cs typeface="Calibri" pitchFamily="34" charset="-120"/>
+              </a:rPr>
+              <a:t>Prefer to run everything yourself? Choose the self-managed upgrade — available on Tier 1 as well</a:t>
+            </a:r>
+            <a:endParaRPr lang="en-US" dirty="0"/>
+          </a:p>
+        </p:txBody>
+      </p:sp>
+      <p:sp>
+        <p:nvSpPr>
+          <p:cNvPr id="4" name="Shape 2"/>
+          <p:cNvSpPr/>
+          <p:nvPr/>
+        </p:nvSpPr>
+        <p:spPr>
+          <a:xfrm>
+            <a:off x="822960" y="1828800"/>
+            <a:ext cx="3017520" cy="731520"/>
+          </a:xfrm>
+          <a:prstGeom prst="rect">
+            <a:avLst/>
+          </a:prstGeom>
+          <a:solidFill>
+            <a:srgbClr val="F3EDFB"/>
+          </a:solidFill>
+          <a:ln/>
+        </p:spPr>
+      </p:sp>
+      <p:sp>
+        <p:nvSpPr>
+          <p:cNvPr id="5" name="Text 3"/>
+          <p:cNvSpPr/>
+          <p:nvPr/>
+        </p:nvSpPr>
+        <p:spPr>
+          <a:xfrm>
+            <a:off x="822960" y="1828800"/>
+            <a:ext cx="3017520" cy="731520"/>
+          </a:xfrm>
+          <a:prstGeom prst="rect">
+            <a:avLst/>
+          </a:prstGeom>
+          <a:noFill/>
+          <a:ln/>
+        </p:spPr>
+        <p:txBody>
+          <a:bodyPr wrap="square" rtlCol="0" anchor="ctr"/>
+          <a:lstStyle/>
+          <a:p>
+            <a:pPr algn="ctr" indent="0" marL="0">
+              <a:buNone/>
+            </a:pPr>
+            <a:r>
+              <a:rPr lang="en-US" sz="1500" b="1" dirty="0">
+                <a:solidFill>
+                  <a:srgbClr val="6F2DBD"/>
+                </a:solidFill>
+                <a:latin typeface="Trebuchet MS" pitchFamily="34" charset="0"/>
+                <a:ea typeface="Trebuchet MS" pitchFamily="34" charset="-122"/>
+                <a:cs typeface="Trebuchet MS" pitchFamily="34" charset="-120"/>
+              </a:rPr>
+              <a:t>2 websites</a:t>
+            </a:r>
+            <a:endParaRPr lang="en-US" sz="1500" dirty="0"/>
+          </a:p>
+        </p:txBody>
+      </p:sp>
+      <p:sp>
+        <p:nvSpPr>
+          <p:cNvPr id="6" name="Text 4"/>
+          <p:cNvSpPr/>
+          <p:nvPr/>
+        </p:nvSpPr>
+        <p:spPr>
+          <a:xfrm>
+            <a:off x="4114800" y="1828800"/>
+            <a:ext cx="7315200" cy="731520"/>
+          </a:xfrm>
+          <a:prstGeom prst="rect">
+            <a:avLst/>
+          </a:prstGeom>
+          <a:noFill/>
+          <a:ln/>
+        </p:spPr>
+        <p:txBody>
+          <a:bodyPr wrap="square" rtlCol="0" anchor="ctr"/>
+          <a:lstStyle/>
+          <a:p>
+            <a:pPr indent="0" marL="0">
+              <a:buNone/>
+            </a:pPr>
+            <a:r>
+              <a:rPr lang="en-US" dirty="0">
+                <a:solidFill>
+                  <a:srgbClr val="725A4A"/>
+                </a:solidFill>
+                <a:latin typeface="Calibri" pitchFamily="34" charset="0"/>
+                <a:ea typeface="Calibri" pitchFamily="34" charset="-122"/>
+                <a:cs typeface="Calibri" pitchFamily="34" charset="-120"/>
+              </a:rPr>
+              <a:t>One public site + one private user/admin site</a:t>
+            </a:r>
+            <a:endParaRPr lang="en-US" dirty="0"/>
+          </a:p>
+        </p:txBody>
+      </p:sp>
+      <p:sp>
+        <p:nvSpPr>
+          <p:cNvPr id="7" name="Shape 5"/>
+          <p:cNvSpPr/>
+          <p:nvPr/>
+        </p:nvSpPr>
+        <p:spPr>
+          <a:xfrm>
+            <a:off x="822960" y="2743200"/>
+            <a:ext cx="3017520" cy="731520"/>
+          </a:xfrm>
+          <a:prstGeom prst="rect">
+            <a:avLst/>
+          </a:prstGeom>
+          <a:solidFill>
+            <a:srgbClr val="F3EDFB"/>
+          </a:solidFill>
+          <a:ln/>
+        </p:spPr>
+      </p:sp>
+      <p:sp>
+        <p:nvSpPr>
+          <p:cNvPr id="8" name="Text 6"/>
+          <p:cNvSpPr/>
+          <p:nvPr/>
+        </p:nvSpPr>
+        <p:spPr>
+          <a:xfrm>
+            <a:off x="822960" y="2743200"/>
+            <a:ext cx="3017520" cy="731520"/>
+          </a:xfrm>
+          <a:prstGeom prst="rect">
+            <a:avLst/>
+          </a:prstGeom>
+          <a:noFill/>
+          <a:ln/>
+        </p:spPr>
+        <p:txBody>
+          <a:bodyPr wrap="square" rtlCol="0" anchor="ctr"/>
+          <a:lstStyle/>
+          <a:p>
+            <a:pPr algn="ctr" indent="0" marL="0">
+              <a:buNone/>
+            </a:pPr>
+            <a:r>
+              <a:rPr lang="en-US" sz="1500" b="1" dirty="0">
+                <a:solidFill>
+                  <a:srgbClr val="6F2DBD"/>
+                </a:solidFill>
+                <a:latin typeface="Trebuchet MS" pitchFamily="34" charset="0"/>
+                <a:ea typeface="Trebuchet MS" pitchFamily="34" charset="-122"/>
+                <a:cs typeface="Trebuchet MS" pitchFamily="34" charset="-120"/>
+              </a:rPr>
+              <a:t>1 backend</a:t>
+            </a:r>
+            <a:endParaRPr lang="en-US" sz="1500" dirty="0"/>
+          </a:p>
+        </p:txBody>
+      </p:sp>
+      <p:sp>
+        <p:nvSpPr>
+          <p:cNvPr id="9" name="Text 7"/>
+          <p:cNvSpPr/>
+          <p:nvPr/>
+        </p:nvSpPr>
+        <p:spPr>
+          <a:xfrm>
+            <a:off x="4114800" y="2743200"/>
+            <a:ext cx="7315200" cy="731520"/>
+          </a:xfrm>
+          <a:prstGeom prst="rect">
+            <a:avLst/>
+          </a:prstGeom>
+          <a:noFill/>
+          <a:ln/>
+        </p:spPr>
+        <p:txBody>
+          <a:bodyPr wrap="square" rtlCol="0" anchor="ctr"/>
+          <a:lstStyle/>
+          <a:p>
+            <a:pPr indent="0" marL="0">
+              <a:buNone/>
+            </a:pPr>
+            <a:r>
+              <a:rPr lang="en-US" dirty="0">
+                <a:solidFill>
+                  <a:srgbClr val="725A4A"/>
+                </a:solidFill>
+                <a:latin typeface="Calibri" pitchFamily="34" charset="0"/>
+                <a:ea typeface="Calibri" pitchFamily="34" charset="-122"/>
+                <a:cs typeface="Calibri" pitchFamily="34" charset="-120"/>
+              </a:rPr>
+              <a:t>An admin store where you manage everything</a:t>
+            </a:r>
+            <a:endParaRPr lang="en-US" dirty="0"/>
+          </a:p>
+        </p:txBody>
+      </p:sp>
+      <p:sp>
+        <p:nvSpPr>
+          <p:cNvPr id="10" name="Shape 8"/>
+          <p:cNvSpPr/>
+          <p:nvPr/>
+        </p:nvSpPr>
+        <p:spPr>
+          <a:xfrm>
+            <a:off x="822960" y="3657600"/>
+            <a:ext cx="3017520" cy="731520"/>
+          </a:xfrm>
+          <a:prstGeom prst="rect">
+            <a:avLst/>
+          </a:prstGeom>
+          <a:solidFill>
+            <a:srgbClr val="F3EDFB"/>
+          </a:solidFill>
+          <a:ln/>
+        </p:spPr>
+      </p:sp>
+      <p:sp>
+        <p:nvSpPr>
+          <p:cNvPr id="11" name="Text 9"/>
+          <p:cNvSpPr/>
+          <p:nvPr/>
+        </p:nvSpPr>
+        <p:spPr>
+          <a:xfrm>
+            <a:off x="822960" y="3657600"/>
+            <a:ext cx="3017520" cy="731520"/>
+          </a:xfrm>
+          <a:prstGeom prst="rect">
+            <a:avLst/>
+          </a:prstGeom>
+          <a:noFill/>
+          <a:ln/>
+        </p:spPr>
+        <p:txBody>
+          <a:bodyPr wrap="square" rtlCol="0" anchor="ctr"/>
+          <a:lstStyle/>
+          <a:p>
+            <a:pPr algn="ctr" indent="0" marL="0">
+              <a:buNone/>
+            </a:pPr>
+            <a:r>
+              <a:rPr lang="en-US" sz="1500" b="1" dirty="0">
+                <a:solidFill>
+                  <a:srgbClr val="6F2DBD"/>
+                </a:solidFill>
+                <a:latin typeface="Trebuchet MS" pitchFamily="34" charset="0"/>
+                <a:ea typeface="Trebuchet MS" pitchFamily="34" charset="-122"/>
+                <a:cs typeface="Trebuchet MS" pitchFamily="34" charset="-120"/>
+              </a:rPr>
+              <a:t>1 database</a:t>
+            </a:r>
+            <a:endParaRPr lang="en-US" sz="1500" dirty="0"/>
+          </a:p>
+        </p:txBody>
+      </p:sp>
+      <p:sp>
+        <p:nvSpPr>
+          <p:cNvPr id="12" name="Text 10"/>
+          <p:cNvSpPr/>
+          <p:nvPr/>
+        </p:nvSpPr>
+        <p:spPr>
+          <a:xfrm>
+            <a:off x="4114800" y="3657600"/>
+            <a:ext cx="7315200" cy="731520"/>
+          </a:xfrm>
+          <a:prstGeom prst="rect">
+            <a:avLst/>
+          </a:prstGeom>
+          <a:noFill/>
+          <a:ln/>
+        </p:spPr>
+        <p:txBody>
+          <a:bodyPr wrap="square" rtlCol="0" anchor="ctr"/>
+          <a:lstStyle/>
+          <a:p>
+            <a:pPr indent="0" marL="0">
+              <a:buNone/>
+            </a:pPr>
+            <a:r>
+              <a:rPr lang="en-US" dirty="0">
+                <a:solidFill>
+                  <a:srgbClr val="725A4A"/>
+                </a:solidFill>
+                <a:latin typeface="Calibri" pitchFamily="34" charset="0"/>
+                <a:ea typeface="Calibri" pitchFamily="34" charset="-122"/>
+                <a:cs typeface="Calibri" pitchFamily="34" charset="-120"/>
+              </a:rPr>
+              <a:t>Your school data stored safely in one place</a:t>
+            </a:r>
+            <a:endParaRPr lang="en-US" dirty="0"/>
+          </a:p>
+        </p:txBody>
+      </p:sp>
+      <p:sp>
+        <p:nvSpPr>
+          <p:cNvPr id="13" name="Shape 11"/>
+          <p:cNvSpPr/>
+          <p:nvPr/>
+        </p:nvSpPr>
+        <p:spPr>
+          <a:xfrm>
+            <a:off x="822960" y="4572000"/>
+            <a:ext cx="3017520" cy="731520"/>
+          </a:xfrm>
+          <a:prstGeom prst="rect">
+            <a:avLst/>
+          </a:prstGeom>
+          <a:solidFill>
+            <a:srgbClr val="F3EDFB"/>
+          </a:solidFill>
+          <a:ln/>
+        </p:spPr>
+      </p:sp>
+      <p:sp>
+        <p:nvSpPr>
+          <p:cNvPr id="14" name="Text 12"/>
+          <p:cNvSpPr/>
+          <p:nvPr/>
+        </p:nvSpPr>
+        <p:spPr>
+          <a:xfrm>
+            <a:off x="822960" y="4572000"/>
+            <a:ext cx="3017520" cy="731520"/>
+          </a:xfrm>
+          <a:prstGeom prst="rect">
+            <a:avLst/>
+          </a:prstGeom>
+          <a:noFill/>
+          <a:ln/>
+        </p:spPr>
+        <p:txBody>
+          <a:bodyPr wrap="square" rtlCol="0" anchor="ctr"/>
+          <a:lstStyle/>
+          <a:p>
+            <a:pPr algn="ctr" indent="0" marL="0">
+              <a:buNone/>
+            </a:pPr>
+            <a:r>
+              <a:rPr lang="en-US" sz="1500" b="1" dirty="0">
+                <a:solidFill>
+                  <a:srgbClr val="6F2DBD"/>
+                </a:solidFill>
+                <a:latin typeface="Trebuchet MS" pitchFamily="34" charset="0"/>
+                <a:ea typeface="Trebuchet MS" pitchFamily="34" charset="-122"/>
+                <a:cs typeface="Trebuchet MS" pitchFamily="34" charset="-120"/>
+              </a:rPr>
+              <a:t>2GB storage</a:t>
+            </a:r>
+            <a:endParaRPr lang="en-US" sz="1500" dirty="0"/>
+          </a:p>
+        </p:txBody>
+      </p:sp>
+      <p:sp>
+        <p:nvSpPr>
+          <p:cNvPr id="15" name="Text 13"/>
+          <p:cNvSpPr/>
+          <p:nvPr/>
+        </p:nvSpPr>
+        <p:spPr>
+          <a:xfrm>
+            <a:off x="4114800" y="4572000"/>
+            <a:ext cx="7315200" cy="731520"/>
+          </a:xfrm>
+          <a:prstGeom prst="rect">
+            <a:avLst/>
+          </a:prstGeom>
+          <a:noFill/>
+          <a:ln/>
+        </p:spPr>
+        <p:txBody>
+          <a:bodyPr wrap="square" rtlCol="0" anchor="ctr"/>
+          <a:lstStyle/>
+          <a:p>
+            <a:pPr indent="0" marL="0">
+              <a:buNone/>
+            </a:pPr>
+            <a:r>
+              <a:rPr lang="en-US" dirty="0">
+                <a:solidFill>
+                  <a:srgbClr val="725A4A"/>
+                </a:solidFill>
+                <a:latin typeface="Calibri" pitchFamily="34" charset="0"/>
+                <a:ea typeface="Calibri" pitchFamily="34" charset="-122"/>
+                <a:cs typeface="Calibri" pitchFamily="34" charset="-120"/>
+              </a:rPr>
+              <a:t>Space for photos, documents and uploads</a:t>
+            </a:r>
+            <a:endParaRPr lang="en-US" dirty="0"/>
+          </a:p>
+        </p:txBody>
+      </p:sp>
+      <p:sp>
+        <p:nvSpPr>
+          <p:cNvPr id="16" name="Shape 14"/>
+          <p:cNvSpPr/>
+          <p:nvPr/>
+        </p:nvSpPr>
+        <p:spPr>
+          <a:xfrm>
+            <a:off x="822960" y="5577840"/>
+            <a:ext cx="10515600" cy="822960"/>
+          </a:xfrm>
+          <a:prstGeom prst="roundRect">
+            <a:avLst>
+              <a:gd name="adj" fmla="val 44444"/>
+            </a:avLst>
+          </a:prstGeom>
+          <a:solidFill>
+            <a:srgbClr val="6F2DBD"/>
+          </a:solidFill>
+          <a:ln w="12700">
+            <a:solidFill>
+              <a:srgbClr val="6F2DBD"/>
+            </a:solidFill>
+            <a:prstDash val="solid"/>
+          </a:ln>
+        </p:spPr>
+      </p:sp>
+      <p:sp>
+        <p:nvSpPr>
+          <p:cNvPr id="17" name="Text 15"/>
+          <p:cNvSpPr/>
+          <p:nvPr/>
+        </p:nvSpPr>
+        <p:spPr>
+          <a:xfrm>
+            <a:off x="822960" y="5577840"/>
+            <a:ext cx="10515600" cy="822960"/>
+          </a:xfrm>
+          <a:prstGeom prst="rect">
+            <a:avLst/>
+          </a:prstGeom>
+          <a:noFill/>
+          <a:ln/>
+        </p:spPr>
+        <p:txBody>
+          <a:bodyPr wrap="square" rtlCol="0" anchor="ctr"/>
+          <a:lstStyle/>
+          <a:p>
+            <a:pPr algn="ctr" indent="0" marL="0">
+              <a:buNone/>
+            </a:pPr>
+            <a:r>
+              <a:rPr lang="en-US" sz="2600" b="1" dirty="0">
+                <a:solidFill>
+                  <a:srgbClr val="FFFFFF"/>
+                </a:solidFill>
+                <a:latin typeface="Trebuchet MS" pitchFamily="34" charset="0"/>
+                <a:ea typeface="Trebuchet MS" pitchFamily="34" charset="-122"/>
+                <a:cs typeface="Trebuchet MS" pitchFamily="34" charset="-120"/>
+              </a:rPr>
+              <a:t>Rs 1,80,000 – Rs 2,00,000</a:t>
+            </a:r>
+            <a:endParaRPr lang="en-US" sz="2600" dirty="0"/>
+          </a:p>
+        </p:txBody>
+      </p:sp>
+    </p:spTree>
+  </p:cSld>
+  <p:clrMapOvr>
+    <a:masterClrMapping/>
+  </p:clrMapOvr>
+</p:sld>
+</file>
+
+<file path=ppt/slides/slide7.xml><?xml version="1.0" encoding="utf-8"?>
+<p:sld xmlns:a="http://schemas.openxmlformats.org/drawingml/2006/main" xmlns:r="http://schemas.openxmlformats.org/officeDocument/2006/relationships" xmlns:p="http://schemas.openxmlformats.org/presentationml/2006/main">
+  <p:cSld name="Slide 7">
     <p:bg>
       <p:bgPr>
         <a:solidFill>
@@ -4851,7 +6478,7 @@
                 <a:ea typeface="Trebuchet MS" pitchFamily="34" charset="-122"/>
                 <a:cs typeface="Trebuchet MS" pitchFamily="34" charset="-120"/>
               </a:rPr>
-              <a:t>Works everywhere</a:t>
+              <a:t>Designs included</a:t>
             </a:r>
             <a:endParaRPr lang="en-US" sz="1600" dirty="0"/>
           </a:p>
@@ -4890,7 +6517,7 @@
                 <a:ea typeface="Calibri" pitchFamily="34" charset="-122"/>
                 <a:cs typeface="Calibri" pitchFamily="34" charset="-120"/>
               </a:rPr>
-              <a:t>Phones, tablets, desktops — tested on a 360px mobile viewport</a:t>
+              <a:t>Logos, banners and graphics you don’t have to commission separately</a:t>
             </a:r>
             <a:endParaRPr lang="en-US" sz="1300" dirty="0"/>
           </a:p>
@@ -4993,7 +6620,7 @@
                 <a:ea typeface="Trebuchet MS" pitchFamily="34" charset="-122"/>
                 <a:cs typeface="Trebuchet MS" pitchFamily="34" charset="-120"/>
               </a:rPr>
-              <a:t>Fast and affordable</a:t>
+              <a:t>Works everywhere</a:t>
             </a:r>
             <a:endParaRPr lang="en-US" sz="1600" dirty="0"/>
           </a:p>
@@ -5032,7 +6659,7 @@
                 <a:ea typeface="Calibri" pitchFamily="34" charset="-122"/>
                 <a:cs typeface="Calibri" pitchFamily="34" charset="-120"/>
               </a:rPr>
-              <a:t>One fixed fee, no surprises, live within weeks</a:t>
+              <a:t>Phones, tablets, desktops — tested on a 360px mobile viewport</a:t>
             </a:r>
             <a:endParaRPr lang="en-US" sz="1300" dirty="0"/>
           </a:p>
@@ -5174,7 +6801,7 @@
                 <a:ea typeface="Calibri" pitchFamily="34" charset="-122"/>
                 <a:cs typeface="Calibri" pitchFamily="34" charset="-120"/>
               </a:rPr>
-              <a:t>Ready to upgrade to Tier 2 with add-ons whenever you need</a:t>
+              <a:t>Upgrade to Tier 2 or the Self-managed option whenever you need</a:t>
             </a:r>
             <a:endParaRPr lang="en-US" sz="1300" dirty="0"/>
           </a:p>
@@ -5188,9 +6815,9 @@
 </p:sld>
 </file>
 
-<file path=ppt/slides/slide6.xml><?xml version="1.0" encoding="utf-8"?>
+<file path=ppt/slides/slide8.xml><?xml version="1.0" encoding="utf-8"?>
 <p:sld xmlns:a="http://schemas.openxmlformats.org/drawingml/2006/main" xmlns:r="http://schemas.openxmlformats.org/officeDocument/2006/relationships" xmlns:p="http://schemas.openxmlformats.org/presentationml/2006/main">
-  <p:cSld name="Slide 6">
+  <p:cSld name="Slide 8">
     <p:bg>
       <p:bgPr>
         <a:solidFill>
@@ -5305,7 +6932,7 @@
               <a:buNone/>
             </a:pPr>
             <a:r>
-              <a:rPr lang="en-US" sz="2200" i="1" dirty="0">
+              <a:rPr lang="en-US" sz="2000" i="1" dirty="0">
                 <a:solidFill>
                   <a:srgbClr val="FFC53D"/>
                 </a:solidFill>
@@ -5313,9 +6940,9 @@
                 <a:ea typeface="Trebuchet MS" pitchFamily="34" charset="-122"/>
                 <a:cs typeface="Trebuchet MS" pitchFamily="34" charset="-120"/>
               </a:rPr>
-              <a:t>Starter Tier — Rs 50,000 + domain charge</a:t>
-            </a:r>
-            <a:endParaRPr lang="en-US" sz="2200" dirty="0"/>
+              <a:t>Starter Tier — Rs 50,000 + domain  |  Self-managed — Rs 1.8–2.0L</a:t>
+            </a:r>
+            <a:endParaRPr lang="en-US" sz="2000" dirty="0"/>
           </a:p>
         </p:txBody>
       </p:sp>

</xml_diff>